<commit_message>
Update project PPT and report
</commit_message>
<xml_diff>
--- a/submission/F2_Team18_PPT.pptx
+++ b/submission/F2_Team18_PPT.pptx
@@ -7,16 +7,20 @@
   <p:sldIdLst>
     <p:sldId id="256" r:id="rId2"/>
     <p:sldId id="257" r:id="rId3"/>
+    <p:sldId id="269" r:id="rId20"/>
     <p:sldId id="258" r:id="rId4"/>
     <p:sldId id="259" r:id="rId5"/>
     <p:sldId id="260" r:id="rId6"/>
     <p:sldId id="261" r:id="rId7"/>
+    <p:sldId id="270" r:id="rId21"/>
     <p:sldId id="262" r:id="rId8"/>
     <p:sldId id="263" r:id="rId9"/>
+    <p:sldId id="271" r:id="rId22"/>
     <p:sldId id="264" r:id="rId10"/>
     <p:sldId id="265" r:id="rId11"/>
     <p:sldId id="266" r:id="rId12"/>
     <p:sldId id="267" r:id="rId13"/>
+    <p:sldId id="272" r:id="rId23"/>
     <p:sldId id="268" r:id="rId14"/>
   </p:sldIdLst>
   <p:notesMasterIdLst>
@@ -2934,8 +2938,8 @@
         </p:nvSpPr>
         <p:spPr>
           <a:xfrm>
-            <a:off x="731520" y="4937760"/>
-            <a:ext cx="7315200" cy="1280160"/>
+            <a:off x="731520" y="4754880"/>
+            <a:ext cx="9144000" cy="1645920"/>
           </a:xfrm>
           <a:prstGeom prst="rect">
             <a:avLst/>
@@ -2956,7 +2960,7 @@
                   <a:srgbClr val="B9D9D4"/>
                 </a:solidFill>
               </a:rPr>
-              <a:t>Slot F2  ·  Team 18</a:t>
+              <a:t>BCSE308P Computer Networks Lab  ·  Fall Semester 2026-27  ·  Slot F2  ·  Team 18</a:t>
             </a:r>
           </a:p>
           <a:p>
@@ -2969,7 +2973,7 @@
                   <a:srgbClr val="B9D9D4"/>
                 </a:solidFill>
               </a:rPr>
-              <a:t>Neha Damani  ·  24BCE2431</a:t>
+              <a:t>24BCE2430  ·  Thipireddy Bhuvana Kruthi</a:t>
             </a:r>
           </a:p>
           <a:p>
@@ -2982,7 +2986,7 @@
                   <a:srgbClr val="B9D9D4"/>
                 </a:solidFill>
               </a:rPr>
-              <a:t>Thipireddy Bhuvana Kruthi  ·  24BCE2430</a:t>
+              <a:t>24BCE2431  ·  Neha Damani</a:t>
             </a:r>
           </a:p>
           <a:p>
@@ -2995,7 +2999,20 @@
                   <a:srgbClr val="B9D9D4"/>
                 </a:solidFill>
               </a:rPr>
-              <a:t>Afreen Faizal  ·  24BCE2514</a:t>
+              <a:t>24BCE2514  ·  Afreen Faizal</a:t>
+            </a:r>
+          </a:p>
+          <a:p>
+            <a:pPr indent="0" marL="0">
+              <a:buNone/>
+            </a:pPr>
+            <a:r>
+              <a:rPr lang="en-US" sz="1400" dirty="0">
+                <a:solidFill>
+                  <a:srgbClr val="B9D9D4"/>
+                </a:solidFill>
+              </a:rPr>
+              <a:t>School of Computer Science and Engineering</a:t>
             </a:r>
           </a:p>
         </p:txBody>
@@ -3057,7 +3074,7 @@
                   <a:schemeClr val="tx2"/>
                 </a:solidFill>
               </a:rPr>
-              <a:t>What the test flow actually experienced</a:t>
+              <a:t>Results: what the test flow actually experienced</a:t>
             </a:r>
             <a:endParaRPr lang="en-US" sz="3400" dirty="0"/>
           </a:p>
@@ -3225,7 +3242,7 @@
                   <a:schemeClr val="tx2"/>
                 </a:solidFill>
               </a:rPr>
-              <a:t>Every decision is explained, and you can watch it live</a:t>
+              <a:t>Analysis: every route change is explained</a:t>
             </a:r>
             <a:endParaRPr lang="en-US" sz="3400" dirty="0"/>
           </a:p>
@@ -3843,7 +3860,7 @@
                   <a:schemeClr val="tx2"/>
                 </a:solidFill>
               </a:rPr>
-              <a:t>Trade-offs, limitations and next steps</a:t>
+              <a:t>Analysis and limitations</a:t>
             </a:r>
             <a:endParaRPr lang="en-US" sz="3400" dirty="0"/>
           </a:p>
@@ -4241,7 +4258,7 @@
                   <a:schemeClr val="tx2"/>
                 </a:solidFill>
               </a:rPr>
-              <a:t>Next steps</a:t>
+              <a:t>When it does not help</a:t>
             </a:r>
             <a:endParaRPr lang="en-US" sz="2000" dirty="0"/>
           </a:p>
@@ -4281,7 +4298,7 @@
                   <a:schemeClr val="tx1"/>
                 </a:solidFill>
               </a:rPr>
-              <a:t>Learn the weights automatically (e.g. Bayesian optimisation).</a:t>
+              <a:t>All paths degraded equally: nothing better to switch to.</a:t>
             </a:r>
             <a:endParaRPr lang="en-US" sz="1600" dirty="0"/>
           </a:p>
@@ -4299,7 +4316,7 @@
                   <a:schemeClr val="tx1"/>
                 </a:solidFill>
               </a:rPr>
-              <a:t>Test in a packet-level emulator such as Mininet or ns-3.</a:t>
+              <a:t>Faults shorter than one probe interval (0.5 s).</a:t>
             </a:r>
             <a:endParaRPr lang="en-US" sz="1600" dirty="0"/>
           </a:p>
@@ -4317,7 +4334,7 @@
                   <a:schemeClr val="tx1"/>
                 </a:solidFill>
               </a:rPr>
-              <a:t>Make it a distributed protocol between routers.</a:t>
+              <a:t>Pure delay faults: latency-only routing does as well.</a:t>
             </a:r>
             <a:endParaRPr lang="en-US" sz="1600" dirty="0"/>
           </a:p>
@@ -4527,6 +4544,3042 @@
 </p:sld>
 </file>
 
+<file path=ppt/slides/slide14.xml><?xml version="1.0" encoding="utf-8"?>
+<p:sld xmlns:a="http://schemas.openxmlformats.org/drawingml/2006/main" xmlns:p="http://schemas.openxmlformats.org/presentationml/2006/main" xmlns:r="http://schemas.openxmlformats.org/officeDocument/2006/relationships">
+  <p:cSld>
+    <p:spTree>
+      <p:nvGrpSpPr>
+        <p:cNvPr id="1" name=""/>
+        <p:cNvGrpSpPr/>
+        <p:nvPr/>
+      </p:nvGrpSpPr>
+      <p:grpSpPr/>
+      <p:sp>
+        <p:nvSpPr>
+          <p:cNvPr id="2" name="Text 0"/>
+          <p:cNvSpPr/>
+          <p:nvPr>
+            <p:ph idx="100" type="title" hasCustomPrompt="1"/>
+          </p:nvPr>
+        </p:nvSpPr>
+        <p:spPr>
+          <a:xfrm>
+            <a:off x="548640" y="365760"/>
+            <a:ext cx="11064240" cy="822960"/>
+          </a:xfrm>
+          <a:prstGeom prst="rect">
+            <a:avLst/>
+          </a:prstGeom>
+          <a:noFill/>
+          <a:ln/>
+        </p:spPr>
+        <p:txBody>
+          <a:bodyPr wrap="square" lIns="0" tIns="0" rIns="0" bIns="0" rtlCol="0" anchor="ctr"/>
+          <a:lstStyle/>
+          <a:p>
+            <a:pPr algn="l" indent="0" marL="0">
+              <a:buNone/>
+            </a:pPr>
+            <a:r>
+              <a:rPr lang="en-US" sz="3400" b="1" dirty="0">
+                <a:solidFill>
+                  <a:schemeClr val="tx2"/>
+                </a:solidFill>
+              </a:rPr>
+              <a:t>Existing approach (baseline) and its gap</a:t>
+            </a:r>
+            <a:endParaRPr lang="en-US" sz="3400" dirty="0"/>
+          </a:p>
+        </p:txBody>
+      </p:sp>
+      <p:sp>
+        <p:nvSpPr>
+          <p:cNvPr id="3" name="col0"/>
+          <p:cNvSpPr/>
+          <p:nvPr/>
+        </p:nvSpPr>
+        <p:spPr>
+          <a:xfrm>
+            <a:off x="548640" y="1508760"/>
+            <a:ext cx="3520440" cy="3749040"/>
+          </a:xfrm>
+          <a:prstGeom prst="roundRect">
+            <a:avLst>
+              <a:gd name="adj" fmla="val 3117"/>
+            </a:avLst>
+          </a:prstGeom>
+          <a:solidFill>
+            <a:srgbClr val="FFF6E0"/>
+          </a:solidFill>
+          <a:ln w="12700">
+            <a:solidFill>
+              <a:srgbClr val="FFF6E0"/>
+            </a:solidFill>
+            <a:prstDash val="solid"/>
+          </a:ln>
+        </p:spPr>
+      </p:sp>
+      <p:sp>
+        <p:nvSpPr>
+          <p:cNvPr id="4" name="Shape 2"/>
+          <p:cNvSpPr/>
+          <p:nvPr/>
+        </p:nvSpPr>
+        <p:spPr>
+          <a:xfrm>
+            <a:off x="822960" y="1783080"/>
+            <a:ext cx="365760" cy="365760"/>
+          </a:xfrm>
+          <a:prstGeom prst="ellipse">
+            <a:avLst/>
+          </a:prstGeom>
+          <a:solidFill>
+            <a:schemeClr val="accent3"/>
+          </a:solidFill>
+          <a:ln w="12700">
+            <a:solidFill>
+              <a:schemeClr val="accent3"/>
+            </a:solidFill>
+            <a:prstDash val="solid"/>
+          </a:ln>
+        </p:spPr>
+      </p:sp>
+      <p:sp>
+        <p:nvSpPr>
+          <p:cNvPr id="5" name="Text 3"/>
+          <p:cNvSpPr txBox="1"/>
+          <p:nvPr/>
+        </p:nvSpPr>
+        <p:spPr>
+          <a:xfrm>
+            <a:off x="1325880" y="1755648"/>
+            <a:ext cx="2560320" cy="411480"/>
+          </a:xfrm>
+          <a:prstGeom prst="rect">
+            <a:avLst/>
+          </a:prstGeom>
+          <a:noFill/>
+          <a:ln/>
+        </p:spPr>
+        <p:txBody>
+          <a:bodyPr wrap="square" lIns="0" tIns="0" rIns="0" bIns="0" rtlCol="0" anchor="ctr"/>
+          <a:lstStyle/>
+          <a:p>
+            <a:pPr indent="0" marL="0">
+              <a:buNone/>
+            </a:pPr>
+            <a:r>
+              <a:rPr lang="en-US" sz="2000" b="1" dirty="0">
+                <a:solidFill>
+                  <a:schemeClr val="tx2"/>
+                </a:solidFill>
+              </a:rPr>
+              <a:t>OSPF (link-state)</a:t>
+            </a:r>
+            <a:endParaRPr lang="en-US" sz="2000" dirty="0"/>
+          </a:p>
+        </p:txBody>
+      </p:sp>
+      <p:sp>
+        <p:nvSpPr>
+          <p:cNvPr id="6" name="Text 4"/>
+          <p:cNvSpPr txBox="1"/>
+          <p:nvPr/>
+        </p:nvSpPr>
+        <p:spPr>
+          <a:xfrm>
+            <a:off x="822960" y="2423160"/>
+            <a:ext cx="3017520" cy="2743200"/>
+          </a:xfrm>
+          <a:prstGeom prst="rect">
+            <a:avLst/>
+          </a:prstGeom>
+          <a:noFill/>
+          <a:ln/>
+        </p:spPr>
+        <p:txBody>
+          <a:bodyPr wrap="square" lIns="0" tIns="0" rIns="0" bIns="0" rtlCol="0" anchor="t"/>
+          <a:lstStyle/>
+          <a:p>
+            <a:pPr marL="342900" indent="-342900">
+              <a:spcAft>
+                <a:spcPts val="800"/>
+              </a:spcAft>
+              <a:buSzPct val="100000"/>
+              <a:buChar char="•"/>
+            </a:pPr>
+            <a:r>
+              <a:rPr lang="en-US" sz="1500" dirty="0">
+                <a:solidFill>
+                  <a:schemeClr val="tx1"/>
+                </a:solidFill>
+              </a:rPr>
+              <a:t>Static cost per link; Dijkstra picks the shortest path.</a:t>
+            </a:r>
+            <a:endParaRPr lang="en-US" sz="1600" dirty="0"/>
+          </a:p>
+          <a:p>
+            <a:pPr marL="342900" indent="-342900">
+              <a:spcAft>
+                <a:spcPts val="800"/>
+              </a:spcAft>
+              <a:buSzPct val="100000"/>
+              <a:buChar char="•"/>
+            </a:pPr>
+            <a:r>
+              <a:rPr lang="en-US" sz="1500" dirty="0">
+                <a:solidFill>
+                  <a:schemeClr val="tx1"/>
+                </a:solidFill>
+              </a:rPr>
+              <a:t>Reacts only when a link is declared down by the dead timer.</a:t>
+            </a:r>
+            <a:endParaRPr lang="en-US" sz="1600" dirty="0"/>
+          </a:p>
+          <a:p>
+            <a:pPr marL="342900" indent="-342900">
+              <a:spcAft>
+                <a:spcPts val="800"/>
+              </a:spcAft>
+              <a:buSzPct val="100000"/>
+              <a:buChar char="•"/>
+            </a:pPr>
+            <a:r>
+              <a:rPr lang="en-US" sz="1500" dirty="0">
+                <a:solidFill>
+                  <a:schemeClr val="tx1"/>
+                </a:solidFill>
+              </a:rPr>
+              <a:t>Gap: keeps using links that are lossy, congested or flapping.</a:t>
+            </a:r>
+            <a:endParaRPr lang="en-US" sz="1600" dirty="0"/>
+          </a:p>
+        </p:txBody>
+      </p:sp>
+      <p:sp>
+        <p:nvSpPr>
+          <p:cNvPr id="7" name="col1"/>
+          <p:cNvSpPr/>
+          <p:nvPr/>
+        </p:nvSpPr>
+        <p:spPr>
+          <a:xfrm>
+            <a:off x="4297680" y="1508760"/>
+            <a:ext cx="3520440" cy="3749040"/>
+          </a:xfrm>
+          <a:prstGeom prst="roundRect">
+            <a:avLst>
+              <a:gd name="adj" fmla="val 3117"/>
+            </a:avLst>
+          </a:prstGeom>
+          <a:solidFill>
+            <a:srgbClr val="FCEDE4"/>
+          </a:solidFill>
+          <a:ln w="12700">
+            <a:solidFill>
+              <a:srgbClr val="FCEDE4"/>
+            </a:solidFill>
+            <a:prstDash val="solid"/>
+          </a:ln>
+        </p:spPr>
+      </p:sp>
+      <p:sp>
+        <p:nvSpPr>
+          <p:cNvPr id="8" name="Shape 6"/>
+          <p:cNvSpPr/>
+          <p:nvPr/>
+        </p:nvSpPr>
+        <p:spPr>
+          <a:xfrm>
+            <a:off x="4572000" y="1783080"/>
+            <a:ext cx="365760" cy="365760"/>
+          </a:xfrm>
+          <a:prstGeom prst="ellipse">
+            <a:avLst/>
+          </a:prstGeom>
+          <a:solidFill>
+            <a:schemeClr val="accent2"/>
+          </a:solidFill>
+          <a:ln w="12700">
+            <a:solidFill>
+              <a:schemeClr val="accent2"/>
+            </a:solidFill>
+            <a:prstDash val="solid"/>
+          </a:ln>
+        </p:spPr>
+      </p:sp>
+      <p:sp>
+        <p:nvSpPr>
+          <p:cNvPr id="9" name="Text 7"/>
+          <p:cNvSpPr txBox="1"/>
+          <p:nvPr/>
+        </p:nvSpPr>
+        <p:spPr>
+          <a:xfrm>
+            <a:off x="5074920" y="1755648"/>
+            <a:ext cx="2560320" cy="411480"/>
+          </a:xfrm>
+          <a:prstGeom prst="rect">
+            <a:avLst/>
+          </a:prstGeom>
+          <a:noFill/>
+          <a:ln/>
+        </p:spPr>
+        <p:txBody>
+          <a:bodyPr wrap="square" lIns="0" tIns="0" rIns="0" bIns="0" rtlCol="0" anchor="ctr"/>
+          <a:lstStyle/>
+          <a:p>
+            <a:pPr indent="0" marL="0">
+              <a:buNone/>
+            </a:pPr>
+            <a:r>
+              <a:rPr lang="en-US" sz="2000" b="1" dirty="0">
+                <a:solidFill>
+                  <a:schemeClr val="tx2"/>
+                </a:solidFill>
+              </a:rPr>
+              <a:t>RIP (distance-vector)</a:t>
+            </a:r>
+            <a:endParaRPr lang="en-US" sz="2000" dirty="0"/>
+          </a:p>
+        </p:txBody>
+      </p:sp>
+      <p:sp>
+        <p:nvSpPr>
+          <p:cNvPr id="10" name="Text 8"/>
+          <p:cNvSpPr txBox="1"/>
+          <p:nvPr/>
+        </p:nvSpPr>
+        <p:spPr>
+          <a:xfrm>
+            <a:off x="4572000" y="2423160"/>
+            <a:ext cx="3017520" cy="2743200"/>
+          </a:xfrm>
+          <a:prstGeom prst="rect">
+            <a:avLst/>
+          </a:prstGeom>
+          <a:noFill/>
+          <a:ln/>
+        </p:spPr>
+        <p:txBody>
+          <a:bodyPr wrap="square" lIns="0" tIns="0" rIns="0" bIns="0" rtlCol="0" anchor="t"/>
+          <a:lstStyle/>
+          <a:p>
+            <a:pPr marL="342900" indent="-342900">
+              <a:spcAft>
+                <a:spcPts val="800"/>
+              </a:spcAft>
+              <a:buSzPct val="100000"/>
+              <a:buChar char="•"/>
+            </a:pPr>
+            <a:r>
+              <a:rPr lang="en-US" sz="1500" dirty="0">
+                <a:solidFill>
+                  <a:schemeClr val="tx1"/>
+                </a:solidFill>
+              </a:rPr>
+              <a:t>Hop count only: every link costs 1.</a:t>
+            </a:r>
+            <a:endParaRPr lang="en-US" sz="1600" dirty="0"/>
+          </a:p>
+          <a:p>
+            <a:pPr marL="342900" indent="-342900">
+              <a:spcAft>
+                <a:spcPts val="800"/>
+              </a:spcAft>
+              <a:buSzPct val="100000"/>
+              <a:buChar char="•"/>
+            </a:pPr>
+            <a:r>
+              <a:rPr lang="en-US" sz="1500" dirty="0">
+                <a:solidFill>
+                  <a:schemeClr val="tx1"/>
+                </a:solidFill>
+              </a:rPr>
+              <a:t>Ignores delay, bandwidth and loss.</a:t>
+            </a:r>
+            <a:endParaRPr lang="en-US" sz="1600" dirty="0"/>
+          </a:p>
+          <a:p>
+            <a:pPr marL="342900" indent="-342900">
+              <a:spcAft>
+                <a:spcPts val="800"/>
+              </a:spcAft>
+              <a:buSzPct val="100000"/>
+              <a:buChar char="•"/>
+            </a:pPr>
+            <a:r>
+              <a:rPr lang="en-US" sz="1500" dirty="0">
+                <a:solidFill>
+                  <a:schemeClr val="tx1"/>
+                </a:solidFill>
+              </a:rPr>
+              <a:t>Gap: blind to link quality and slow to converge.</a:t>
+            </a:r>
+            <a:endParaRPr lang="en-US" sz="1600" dirty="0"/>
+          </a:p>
+        </p:txBody>
+      </p:sp>
+      <p:sp>
+        <p:nvSpPr>
+          <p:cNvPr id="11" name="col2"/>
+          <p:cNvSpPr/>
+          <p:nvPr/>
+        </p:nvSpPr>
+        <p:spPr>
+          <a:xfrm>
+            <a:off x="8046720" y="1508760"/>
+            <a:ext cx="3520440" cy="3749040"/>
+          </a:xfrm>
+          <a:prstGeom prst="roundRect">
+            <a:avLst>
+              <a:gd name="adj" fmla="val 3117"/>
+            </a:avLst>
+          </a:prstGeom>
+          <a:solidFill>
+            <a:srgbClr val="E3F2EF"/>
+          </a:solidFill>
+          <a:ln w="12700">
+            <a:solidFill>
+              <a:srgbClr val="E3F2EF"/>
+            </a:solidFill>
+            <a:prstDash val="solid"/>
+          </a:ln>
+        </p:spPr>
+      </p:sp>
+      <p:sp>
+        <p:nvSpPr>
+          <p:cNvPr id="12" name="Shape 10"/>
+          <p:cNvSpPr/>
+          <p:nvPr/>
+        </p:nvSpPr>
+        <p:spPr>
+          <a:xfrm>
+            <a:off x="8321040" y="1783080"/>
+            <a:ext cx="365760" cy="365760"/>
+          </a:xfrm>
+          <a:prstGeom prst="ellipse">
+            <a:avLst/>
+          </a:prstGeom>
+          <a:solidFill>
+            <a:schemeClr val="accent1"/>
+          </a:solidFill>
+          <a:ln w="12700">
+            <a:solidFill>
+              <a:schemeClr val="accent1"/>
+            </a:solidFill>
+            <a:prstDash val="solid"/>
+          </a:ln>
+        </p:spPr>
+      </p:sp>
+      <p:sp>
+        <p:nvSpPr>
+          <p:cNvPr id="13" name="Text 11"/>
+          <p:cNvSpPr txBox="1"/>
+          <p:nvPr/>
+        </p:nvSpPr>
+        <p:spPr>
+          <a:xfrm>
+            <a:off x="8823960" y="1755648"/>
+            <a:ext cx="2560320" cy="411480"/>
+          </a:xfrm>
+          <a:prstGeom prst="rect">
+            <a:avLst/>
+          </a:prstGeom>
+          <a:noFill/>
+          <a:ln/>
+        </p:spPr>
+        <p:txBody>
+          <a:bodyPr wrap="square" lIns="0" tIns="0" rIns="0" bIns="0" rtlCol="0" anchor="ctr"/>
+          <a:lstStyle/>
+          <a:p>
+            <a:pPr indent="0" marL="0">
+              <a:buNone/>
+            </a:pPr>
+            <a:r>
+              <a:rPr lang="en-US" sz="2000" b="1" dirty="0">
+                <a:solidFill>
+                  <a:schemeClr val="tx2"/>
+                </a:solidFill>
+              </a:rPr>
+              <a:t>Latency-only dynamic</a:t>
+            </a:r>
+            <a:endParaRPr lang="en-US" sz="2000" dirty="0"/>
+          </a:p>
+        </p:txBody>
+      </p:sp>
+      <p:sp>
+        <p:nvSpPr>
+          <p:cNvPr id="14" name="Text 12"/>
+          <p:cNvSpPr txBox="1"/>
+          <p:nvPr/>
+        </p:nvSpPr>
+        <p:spPr>
+          <a:xfrm>
+            <a:off x="8321040" y="2423160"/>
+            <a:ext cx="3017520" cy="2743200"/>
+          </a:xfrm>
+          <a:prstGeom prst="rect">
+            <a:avLst/>
+          </a:prstGeom>
+          <a:noFill/>
+          <a:ln/>
+        </p:spPr>
+        <p:txBody>
+          <a:bodyPr wrap="square" lIns="0" tIns="0" rIns="0" bIns="0" rtlCol="0" anchor="t"/>
+          <a:lstStyle/>
+          <a:p>
+            <a:pPr marL="342900" indent="-342900">
+              <a:spcAft>
+                <a:spcPts val="800"/>
+              </a:spcAft>
+              <a:buSzPct val="100000"/>
+              <a:buChar char="•"/>
+            </a:pPr>
+            <a:r>
+              <a:rPr lang="en-US" sz="1500" dirty="0">
+                <a:solidFill>
+                  <a:schemeClr val="tx1"/>
+                </a:solidFill>
+              </a:rPr>
+              <a:t>Re-routes on measured delay and queueing.</a:t>
+            </a:r>
+            <a:endParaRPr lang="en-US" sz="1600" dirty="0"/>
+          </a:p>
+          <a:p>
+            <a:pPr marL="342900" indent="-342900">
+              <a:spcAft>
+                <a:spcPts val="800"/>
+              </a:spcAft>
+              <a:buSzPct val="100000"/>
+              <a:buChar char="•"/>
+            </a:pPr>
+            <a:r>
+              <a:rPr lang="en-US" sz="1500" dirty="0">
+                <a:solidFill>
+                  <a:schemeClr val="tx1"/>
+                </a:solidFill>
+              </a:rPr>
+              <a:t>Handles delay spikes and congestion.</a:t>
+            </a:r>
+            <a:endParaRPr lang="en-US" sz="1600" dirty="0"/>
+          </a:p>
+          <a:p>
+            <a:pPr marL="342900" indent="-342900">
+              <a:spcAft>
+                <a:spcPts val="800"/>
+              </a:spcAft>
+              <a:buSzPct val="100000"/>
+              <a:buChar char="•"/>
+            </a:pPr>
+            <a:r>
+              <a:rPr lang="en-US" sz="1500" dirty="0">
+                <a:solidFill>
+                  <a:schemeClr val="tx1"/>
+                </a:solidFill>
+              </a:rPr>
+              <a:t>Gap: misses packet loss and flapping, which do not raise delay.</a:t>
+            </a:r>
+            <a:endParaRPr lang="en-US" sz="1600" dirty="0"/>
+          </a:p>
+        </p:txBody>
+      </p:sp>
+      <p:sp>
+        <p:nvSpPr>
+          <p:cNvPr id="15" name="Text 13"/>
+          <p:cNvSpPr txBox="1"/>
+          <p:nvPr/>
+        </p:nvSpPr>
+        <p:spPr>
+          <a:xfrm>
+            <a:off x="548640" y="5577840"/>
+            <a:ext cx="11064240" cy="411480"/>
+          </a:xfrm>
+          <a:prstGeom prst="rect">
+            <a:avLst/>
+          </a:prstGeom>
+          <a:noFill/>
+          <a:ln/>
+        </p:spPr>
+        <p:txBody>
+          <a:bodyPr wrap="square" lIns="0" tIns="0" rIns="0" bIns="0" rtlCol="0" anchor="t"/>
+          <a:lstStyle/>
+          <a:p>
+            <a:pPr indent="0" marL="0">
+              <a:buNone/>
+            </a:pPr>
+            <a:r>
+              <a:rPr lang="en-US" sz="1500" i="1" dirty="0">
+                <a:solidFill>
+                  <a:schemeClr val="accent4"/>
+                </a:solidFill>
+              </a:rPr>
+              <a:t>Main baseline: OSPF-like static routing. All policies share the same probes and dead timer, so only the routing logic differs.</a:t>
+            </a:r>
+            <a:endParaRPr lang="en-US" sz="1500" dirty="0"/>
+          </a:p>
+        </p:txBody>
+      </p:sp>
+      <p:sp>
+        <p:nvSpPr>
+          <p:cNvPr id="25" name="Slide Number Placeholder 0"/>
+          <p:cNvSpPr>
+            <a:spLocks noGrp="1"/>
+          </p:cNvSpPr>
+          <p:nvPr>
+            <p:ph type="sldNum" sz="quarter" idx="4294967295"/>
+          </p:nvPr>
+        </p:nvSpPr>
+        <p:spPr>
+          <a:xfrm>
+            <a:off x="11247120" y="6400800"/>
+            <a:ext cx="548640" cy="274320"/>
+          </a:xfrm>
+          <a:prstGeom prst="rect">
+            <a:avLst/>
+          </a:prstGeom>
+          <a:extLst>
+            <a:ext uri="{C572A759-6A51-4108-AA02-DFA0A04FC94B}">
+              <ma14:wrappingTextBoxFlag xmlns:ma14="http://schemas.microsoft.com/office/mac/drawingml/2011/main" val="0"/>
+            </a:ext>
+          </a:extLst>
+        </p:spPr>
+        <p:txBody>
+          <a:bodyPr/>
+          <a:lstStyle>
+            <a:lvl1pPr>
+              <a:defRPr sz="1000">
+                <a:solidFill>
+                  <a:srgbClr val="8A949B"/>
+                </a:solidFill>
+              </a:defRPr>
+            </a:lvl1pPr>
+          </a:lstStyle>
+          <a:p>
+            <a:pPr algn="r"/>
+            <a:fld id="{F7021451-1387-4CA6-816F-3879F97B5CBC}" type="slidenum">
+              <a:rPr b="0" lang="en-US"/>
+              <a:t>12</a:t>
+            </a:fld>
+            <a:endParaRPr lang="en-US"/>
+          </a:p>
+        </p:txBody>
+      </p:sp>
+    </p:spTree>
+  </p:cSld>
+  <p:clrMapOvr>
+    <a:masterClrMapping/>
+  </p:clrMapOvr>
+</p:sld>
+</file>
+
+<file path=ppt/slides/slide15.xml><?xml version="1.0" encoding="utf-8"?>
+<p:sld xmlns:a="http://schemas.openxmlformats.org/drawingml/2006/main" xmlns:p="http://schemas.openxmlformats.org/presentationml/2006/main" xmlns:r="http://schemas.openxmlformats.org/officeDocument/2006/relationships">
+  <p:cSld>
+    <p:spTree>
+      <p:nvGrpSpPr>
+        <p:cNvPr id="1" name=""/>
+        <p:cNvGrpSpPr/>
+        <p:nvPr/>
+      </p:nvGrpSpPr>
+      <p:grpSpPr/>
+      <p:sp>
+        <p:nvSpPr>
+          <p:cNvPr id="2" name="Text 0"/>
+          <p:cNvSpPr/>
+          <p:nvPr>
+            <p:ph idx="100" type="title" hasCustomPrompt="1"/>
+          </p:nvPr>
+        </p:nvSpPr>
+        <p:spPr>
+          <a:xfrm>
+            <a:off x="548640" y="365760"/>
+            <a:ext cx="11064240" cy="822960"/>
+          </a:xfrm>
+          <a:prstGeom prst="rect">
+            <a:avLst/>
+          </a:prstGeom>
+          <a:noFill/>
+          <a:ln/>
+        </p:spPr>
+        <p:txBody>
+          <a:bodyPr wrap="square" lIns="0" tIns="0" rIns="0" bIns="0" rtlCol="0" anchor="ctr"/>
+          <a:lstStyle/>
+          <a:p>
+            <a:pPr algn="l" indent="0" marL="0">
+              <a:buNone/>
+            </a:pPr>
+            <a:r>
+              <a:rPr lang="en-US" sz="3400" b="1" dirty="0">
+                <a:solidFill>
+                  <a:schemeClr val="tx2"/>
+                </a:solidFill>
+              </a:rPr>
+              <a:t>Implementation setup</a:t>
+            </a:r>
+            <a:endParaRPr lang="en-US" sz="3400" dirty="0"/>
+          </a:p>
+        </p:txBody>
+      </p:sp>
+      <p:sp>
+        <p:nvSpPr>
+          <p:cNvPr id="3" name="log"/>
+          <p:cNvSpPr/>
+          <p:nvPr/>
+        </p:nvSpPr>
+        <p:spPr>
+          <a:xfrm>
+            <a:off x="548640" y="1463040"/>
+            <a:ext cx="6400800" cy="4480560"/>
+          </a:xfrm>
+          <a:prstGeom prst="roundRect">
+            <a:avLst>
+              <a:gd name="adj" fmla="val 2449"/>
+            </a:avLst>
+          </a:prstGeom>
+          <a:solidFill>
+            <a:schemeClr val="tx2"/>
+          </a:solidFill>
+          <a:ln w="12700">
+            <a:solidFill>
+              <a:schemeClr val="tx2"/>
+            </a:solidFill>
+            <a:prstDash val="solid"/>
+          </a:ln>
+        </p:spPr>
+      </p:sp>
+      <p:sp>
+        <p:nvSpPr>
+          <p:cNvPr id="4" name="Text 2"/>
+          <p:cNvSpPr txBox="1"/>
+          <p:nvPr/>
+        </p:nvSpPr>
+        <p:spPr>
+          <a:xfrm>
+            <a:off x="822960" y="1691640"/>
+            <a:ext cx="5852160" cy="365760"/>
+          </a:xfrm>
+          <a:prstGeom prst="rect">
+            <a:avLst/>
+          </a:prstGeom>
+          <a:noFill/>
+          <a:ln/>
+        </p:spPr>
+        <p:txBody>
+          <a:bodyPr wrap="square" lIns="0" tIns="0" rIns="0" bIns="0" rtlCol="0" anchor="t"/>
+          <a:lstStyle/>
+          <a:p>
+            <a:pPr indent="0" marL="0">
+              <a:buNone/>
+            </a:pPr>
+            <a:r>
+              <a:rPr lang="en-US" sz="1700" b="1" dirty="0">
+                <a:solidFill>
+                  <a:srgbClr val="B9D9D4"/>
+                </a:solidFill>
+              </a:rPr>
+              <a:t>Code structure (Python package irp/)</a:t>
+            </a:r>
+            <a:endParaRPr lang="en-US" sz="1700" dirty="0"/>
+          </a:p>
+        </p:txBody>
+      </p:sp>
+      <p:sp>
+        <p:nvSpPr>
+          <p:cNvPr id="5" name="Text 3"/>
+          <p:cNvSpPr txBox="1"/>
+          <p:nvPr/>
+        </p:nvSpPr>
+        <p:spPr>
+          <a:xfrm>
+            <a:off x="822960" y="2240280"/>
+            <a:ext cx="5943600" cy="3474720"/>
+          </a:xfrm>
+          <a:prstGeom prst="rect">
+            <a:avLst/>
+          </a:prstGeom>
+          <a:noFill/>
+          <a:ln/>
+        </p:spPr>
+        <p:txBody>
+          <a:bodyPr wrap="square" lIns="0" tIns="0" rIns="0" bIns="0" rtlCol="0" anchor="t"/>
+          <a:lstStyle/>
+          <a:p>
+            <a:pPr indent="0" marL="0">
+              <a:spcAft>
+                <a:spcPts val="400"/>
+              </a:spcAft>
+              <a:buNone/>
+            </a:pPr>
+            <a:r>
+              <a:rPr lang="en-US" sz="1400" dirty="0">
+                <a:solidFill>
+                  <a:srgbClr val="F6C08F"/>
+                </a:solidFill>
+                <a:latin typeface="Courier New" pitchFamily="34" charset="0"/>
+                <a:ea typeface="Courier New" pitchFamily="34" charset="-122"/>
+                <a:cs typeface="Courier New" pitchFamily="34" charset="-120"/>
+              </a:rPr>
+              <a:t>topology.py    routers, links, queue model</a:t>
+            </a:r>
+            <a:endParaRPr lang="en-US" sz="1500" dirty="0"/>
+          </a:p>
+          <a:p>
+            <a:pPr indent="0" marL="0">
+              <a:spcAft>
+                <a:spcPts val="400"/>
+              </a:spcAft>
+              <a:buNone/>
+            </a:pPr>
+            <a:r>
+              <a:rPr lang="en-US" sz="1400" dirty="0">
+                <a:solidFill>
+                  <a:srgbClr val="F6C08F"/>
+                </a:solidFill>
+                <a:latin typeface="Courier New" pitchFamily="34" charset="0"/>
+                <a:ea typeface="Courier New" pitchFamily="34" charset="-122"/>
+                <a:cs typeface="Courier New" pitchFamily="34" charset="-120"/>
+              </a:rPr>
+              <a:t>monitor.py     probes, EWMA, dead timer</a:t>
+            </a:r>
+            <a:endParaRPr lang="en-US" sz="1500" dirty="0"/>
+          </a:p>
+          <a:p>
+            <a:pPr indent="0" marL="0">
+              <a:spcAft>
+                <a:spcPts val="400"/>
+              </a:spcAft>
+              <a:buNone/>
+            </a:pPr>
+            <a:r>
+              <a:rPr lang="en-US" sz="1400" dirty="0">
+                <a:solidFill>
+                  <a:srgbClr val="F6C08F"/>
+                </a:solidFill>
+                <a:latin typeface="Courier New" pitchFamily="34" charset="0"/>
+                <a:ea typeface="Courier New" pitchFamily="34" charset="-122"/>
+                <a:cs typeface="Courier New" pitchFamily="34" charset="-120"/>
+              </a:rPr>
+              <a:t>policies.py    IRP cost + 3 baselines</a:t>
+            </a:r>
+            <a:endParaRPr lang="en-US" sz="1500" dirty="0"/>
+          </a:p>
+          <a:p>
+            <a:pPr indent="0" marL="0">
+              <a:spcAft>
+                <a:spcPts val="400"/>
+              </a:spcAft>
+              <a:buNone/>
+            </a:pPr>
+            <a:r>
+              <a:rPr lang="en-US" sz="1400" dirty="0">
+                <a:solidFill>
+                  <a:srgbClr val="F6C08F"/>
+                </a:solidFill>
+                <a:latin typeface="Courier New" pitchFamily="34" charset="0"/>
+                <a:ea typeface="Courier New" pitchFamily="34" charset="-122"/>
+                <a:cs typeface="Courier New" pitchFamily="34" charset="-120"/>
+              </a:rPr>
+              <a:t>engine.py      Dijkstra, hysteresis,</a:t>
+            </a:r>
+            <a:endParaRPr lang="en-US" sz="1500" dirty="0"/>
+          </a:p>
+          <a:p>
+            <a:pPr indent="0" marL="0">
+              <a:spcAft>
+                <a:spcPts val="400"/>
+              </a:spcAft>
+              <a:buNone/>
+            </a:pPr>
+            <a:r>
+              <a:rPr lang="en-US" sz="1400" dirty="0">
+                <a:solidFill>
+                  <a:srgbClr val="F6C08F"/>
+                </a:solidFill>
+                <a:latin typeface="Courier New" pitchFamily="34" charset="0"/>
+                <a:ea typeface="Courier New" pitchFamily="34" charset="-122"/>
+                <a:cs typeface="Courier New" pitchFamily="34" charset="-120"/>
+              </a:rPr>
+              <a:t>               hold-down, change reasons</a:t>
+            </a:r>
+            <a:endParaRPr lang="en-US" sz="1500" dirty="0"/>
+          </a:p>
+          <a:p>
+            <a:pPr indent="0" marL="0">
+              <a:spcAft>
+                <a:spcPts val="400"/>
+              </a:spcAft>
+              <a:buNone/>
+            </a:pPr>
+            <a:r>
+              <a:rPr lang="en-US" sz="1400" dirty="0">
+                <a:solidFill>
+                  <a:srgbClr val="F6C08F"/>
+                </a:solidFill>
+                <a:latin typeface="Courier New" pitchFamily="34" charset="0"/>
+                <a:ea typeface="Courier New" pitchFamily="34" charset="-122"/>
+                <a:cs typeface="Courier New" pitchFamily="34" charset="-120"/>
+              </a:rPr>
+              <a:t>simulator.py   100 ms ticks, fault events</a:t>
+            </a:r>
+            <a:endParaRPr lang="en-US" sz="1500" dirty="0"/>
+          </a:p>
+          <a:p>
+            <a:pPr indent="0" marL="0">
+              <a:spcAft>
+                <a:spcPts val="400"/>
+              </a:spcAft>
+              <a:buNone/>
+            </a:pPr>
+            <a:r>
+              <a:rPr lang="en-US" sz="1400" dirty="0">
+                <a:solidFill>
+                  <a:srgbClr val="F6C08F"/>
+                </a:solidFill>
+                <a:latin typeface="Courier New" pitchFamily="34" charset="0"/>
+                <a:ea typeface="Courier New" pitchFamily="34" charset="-122"/>
+                <a:cs typeface="Courier New" pitchFamily="34" charset="-120"/>
+              </a:rPr>
+              <a:t>scenarios.py   mesh8 topology, 9 tests</a:t>
+            </a:r>
+            <a:endParaRPr lang="en-US" sz="1500" dirty="0"/>
+          </a:p>
+          <a:p>
+            <a:pPr indent="0" marL="0">
+              <a:spcAft>
+                <a:spcPts val="400"/>
+              </a:spcAft>
+              <a:buNone/>
+            </a:pPr>
+            <a:r>
+              <a:rPr lang="en-US" sz="1400" dirty="0">
+                <a:solidFill>
+                  <a:srgbClr val="F6C08F"/>
+                </a:solidFill>
+                <a:latin typeface="Courier New" pitchFamily="34" charset="0"/>
+                <a:ea typeface="Courier New" pitchFamily="34" charset="-122"/>
+                <a:cs typeface="Courier New" pitchFamily="34" charset="-120"/>
+              </a:rPr>
+              <a:t>evaluation.py  10 seeds, CIs, t-tests</a:t>
+            </a:r>
+            <a:endParaRPr lang="en-US" sz="1500" dirty="0"/>
+          </a:p>
+          <a:p>
+            <a:pPr indent="0" marL="0">
+              <a:spcAft>
+                <a:spcPts val="400"/>
+              </a:spcAft>
+              <a:buNone/>
+            </a:pPr>
+            <a:r>
+              <a:rPr lang="en-US" sz="1400" dirty="0">
+                <a:solidFill>
+                  <a:srgbClr val="F6C08F"/>
+                </a:solidFill>
+                <a:latin typeface="Courier New" pitchFamily="34" charset="0"/>
+                <a:ea typeface="Courier New" pitchFamily="34" charset="-122"/>
+                <a:cs typeface="Courier New" pitchFamily="34" charset="-120"/>
+              </a:rPr>
+              <a:t>dashboard/     Streamlit app</a:t>
+            </a:r>
+            <a:endParaRPr lang="en-US" sz="1500" dirty="0"/>
+          </a:p>
+          <a:p>
+            <a:pPr indent="0" marL="0">
+              <a:spcAft>
+                <a:spcPts val="400"/>
+              </a:spcAft>
+              <a:buNone/>
+            </a:pPr>
+            <a:r>
+              <a:rPr lang="en-US" sz="1400" dirty="0">
+                <a:solidFill>
+                  <a:srgbClr val="F6C08F"/>
+                </a:solidFill>
+                <a:latin typeface="Courier New" pitchFamily="34" charset="0"/>
+                <a:ea typeface="Courier New" pitchFamily="34" charset="-122"/>
+                <a:cs typeface="Courier New" pitchFamily="34" charset="-120"/>
+              </a:rPr>
+              <a:t>tests/         29 pytest tests</a:t>
+            </a:r>
+            <a:endParaRPr lang="en-US" sz="1500" dirty="0"/>
+          </a:p>
+        </p:txBody>
+      </p:sp>
+      <p:sp>
+        <p:nvSpPr>
+          <p:cNvPr id="6" name="Text 4"/>
+          <p:cNvSpPr txBox="1"/>
+          <p:nvPr/>
+        </p:nvSpPr>
+        <p:spPr>
+          <a:xfrm>
+            <a:off x="7315200" y="1463040"/>
+            <a:ext cx="4297680" cy="411480"/>
+          </a:xfrm>
+          <a:prstGeom prst="rect">
+            <a:avLst/>
+          </a:prstGeom>
+          <a:noFill/>
+          <a:ln/>
+        </p:spPr>
+        <p:txBody>
+          <a:bodyPr wrap="square" lIns="0" tIns="0" rIns="0" bIns="0" rtlCol="0" anchor="t"/>
+          <a:lstStyle/>
+          <a:p>
+            <a:pPr indent="0" marL="0">
+              <a:buNone/>
+            </a:pPr>
+            <a:r>
+              <a:rPr lang="en-US" sz="2000" b="1" dirty="0">
+                <a:solidFill>
+                  <a:schemeClr val="tx2"/>
+                </a:solidFill>
+              </a:rPr>
+              <a:t>Tools and platform</a:t>
+            </a:r>
+            <a:endParaRPr lang="en-US" sz="2000" dirty="0"/>
+          </a:p>
+        </p:txBody>
+      </p:sp>
+      <p:sp>
+        <p:nvSpPr>
+          <p:cNvPr id="7" name="Text 5"/>
+          <p:cNvSpPr txBox="1"/>
+          <p:nvPr/>
+        </p:nvSpPr>
+        <p:spPr>
+          <a:xfrm>
+            <a:off x="7315200" y="1965960"/>
+            <a:ext cx="4297680" cy="2377440"/>
+          </a:xfrm>
+          <a:prstGeom prst="rect">
+            <a:avLst/>
+          </a:prstGeom>
+          <a:noFill/>
+          <a:ln/>
+        </p:spPr>
+        <p:txBody>
+          <a:bodyPr wrap="square" lIns="0" tIns="0" rIns="0" bIns="0" rtlCol="0" anchor="t"/>
+          <a:lstStyle/>
+          <a:p>
+            <a:pPr marL="342900" indent="-342900">
+              <a:spcAft>
+                <a:spcPts val="600"/>
+              </a:spcAft>
+              <a:buSzPct val="100000"/>
+              <a:buChar char="•"/>
+            </a:pPr>
+            <a:r>
+              <a:rPr lang="en-US" sz="1500" dirty="0">
+                <a:solidFill>
+                  <a:schemeClr val="tx1"/>
+                </a:solidFill>
+              </a:rPr>
+              <a:t>Python 3.14; the protocol core uses only the standard library</a:t>
+            </a:r>
+            <a:endParaRPr lang="en-US" sz="1600" dirty="0"/>
+          </a:p>
+          <a:p>
+            <a:pPr marL="342900" indent="-342900">
+              <a:spcAft>
+                <a:spcPts val="600"/>
+              </a:spcAft>
+              <a:buSzPct val="100000"/>
+              <a:buChar char="•"/>
+            </a:pPr>
+            <a:r>
+              <a:rPr lang="en-US" sz="1500" dirty="0">
+                <a:solidFill>
+                  <a:schemeClr val="tx1"/>
+                </a:solidFill>
+              </a:rPr>
+              <a:t>pandas, SciPy, Matplotlib, Plotly, Streamlit, pytest</a:t>
+            </a:r>
+            <a:endParaRPr lang="en-US" sz="1600" dirty="0"/>
+          </a:p>
+          <a:p>
+            <a:pPr marL="342900" indent="-342900">
+              <a:spcAft>
+                <a:spcPts val="600"/>
+              </a:spcAft>
+              <a:buSzPct val="100000"/>
+              <a:buChar char="•"/>
+            </a:pPr>
+            <a:r>
+              <a:rPr lang="en-US" sz="1500" dirty="0">
+                <a:solidFill>
+                  <a:schemeClr val="tx1"/>
+                </a:solidFill>
+              </a:rPr>
+              <a:t>macOS on Apple M4, 16 GB RAM; VS Code and Git</a:t>
+            </a:r>
+            <a:endParaRPr lang="en-US" sz="1600" dirty="0"/>
+          </a:p>
+          <a:p>
+            <a:pPr marL="342900" indent="-342900">
+              <a:spcAft>
+                <a:spcPts val="600"/>
+              </a:spcAft>
+              <a:buSzPct val="100000"/>
+              <a:buChar char="•"/>
+            </a:pPr>
+            <a:r>
+              <a:rPr lang="en-US" sz="1500" dirty="0">
+                <a:solidFill>
+                  <a:schemeClr val="tx1"/>
+                </a:solidFill>
+              </a:rPr>
+              <a:t>Simulator: 100 ms ticks, probes every 0.5 s, 60 s runs</a:t>
+            </a:r>
+            <a:endParaRPr lang="en-US" sz="1600" dirty="0"/>
+          </a:p>
+        </p:txBody>
+      </p:sp>
+      <p:sp>
+        <p:nvSpPr>
+          <p:cNvPr id="8" name="runCmd"/>
+          <p:cNvSpPr/>
+          <p:nvPr/>
+        </p:nvSpPr>
+        <p:spPr>
+          <a:xfrm>
+            <a:off x="7315200" y="4572000"/>
+            <a:ext cx="4297680" cy="1371600"/>
+          </a:xfrm>
+          <a:prstGeom prst="roundRect">
+            <a:avLst>
+              <a:gd name="adj" fmla="val 8000"/>
+            </a:avLst>
+          </a:prstGeom>
+          <a:solidFill>
+            <a:srgbClr val="E3F2EF"/>
+          </a:solidFill>
+          <a:ln w="12700">
+            <a:solidFill>
+              <a:srgbClr val="E3F2EF"/>
+            </a:solidFill>
+            <a:prstDash val="solid"/>
+          </a:ln>
+        </p:spPr>
+      </p:sp>
+      <p:sp>
+        <p:nvSpPr>
+          <p:cNvPr id="9" name="Text 7"/>
+          <p:cNvSpPr txBox="1"/>
+          <p:nvPr/>
+        </p:nvSpPr>
+        <p:spPr>
+          <a:xfrm>
+            <a:off x="7543800" y="4663440"/>
+            <a:ext cx="3931920" cy="1188720"/>
+          </a:xfrm>
+          <a:prstGeom prst="rect">
+            <a:avLst/>
+          </a:prstGeom>
+          <a:noFill/>
+          <a:ln/>
+        </p:spPr>
+        <p:txBody>
+          <a:bodyPr wrap="square" lIns="0" tIns="0" rIns="0" bIns="0" rtlCol="0" anchor="ctr"/>
+          <a:lstStyle/>
+          <a:p>
+            <a:pPr indent="0" marL="0">
+              <a:buNone/>
+            </a:pPr>
+            <a:r>
+              <a:rPr lang="en-US" sz="1500" b="1" dirty="0">
+                <a:solidFill>
+                  <a:schemeClr val="tx2"/>
+                </a:solidFill>
+              </a:rPr>
+              <a:t>Run it</a:t>
+            </a:r>
+            <a:endParaRPr lang="en-US" sz="1500" dirty="0"/>
+          </a:p>
+          <a:p>
+            <a:pPr indent="0" marL="0">
+              <a:buNone/>
+            </a:pPr>
+            <a:r>
+              <a:rPr lang="en-US" sz="1500" dirty="0">
+                <a:solidFill>
+                  <a:schemeClr val="tx1"/>
+                </a:solidFill>
+                <a:latin typeface="Courier New" pitchFamily="34" charset="0"/>
+                <a:ea typeface="Courier New" pitchFamily="34" charset="-122"/>
+                <a:cs typeface="Courier New" pitchFamily="34" charset="-120"/>
+              </a:rPr>
+              <a:t>python -m irp evaluate</a:t>
+            </a:r>
+            <a:endParaRPr lang="en-US" sz="1500" dirty="0"/>
+          </a:p>
+          <a:p>
+            <a:pPr indent="0" marL="0">
+              <a:buNone/>
+            </a:pPr>
+            <a:r>
+              <a:rPr lang="en-US" sz="1500" dirty="0">
+                <a:solidFill>
+                  <a:schemeClr val="tx1"/>
+                </a:solidFill>
+                <a:latin typeface="Courier New" pitchFamily="34" charset="0"/>
+                <a:ea typeface="Courier New" pitchFamily="34" charset="-122"/>
+                <a:cs typeface="Courier New" pitchFamily="34" charset="-120"/>
+              </a:rPr>
+              <a:t>python -m irp dashboard</a:t>
+            </a:r>
+            <a:endParaRPr lang="en-US" sz="1500" dirty="0"/>
+          </a:p>
+        </p:txBody>
+      </p:sp>
+      <p:sp>
+        <p:nvSpPr>
+          <p:cNvPr id="25" name="Slide Number Placeholder 0"/>
+          <p:cNvSpPr>
+            <a:spLocks noGrp="1"/>
+          </p:cNvSpPr>
+          <p:nvPr>
+            <p:ph type="sldNum" sz="quarter" idx="4294967295"/>
+          </p:nvPr>
+        </p:nvSpPr>
+        <p:spPr>
+          <a:xfrm>
+            <a:off x="11247120" y="6400800"/>
+            <a:ext cx="548640" cy="274320"/>
+          </a:xfrm>
+          <a:prstGeom prst="rect">
+            <a:avLst/>
+          </a:prstGeom>
+          <a:extLst>
+            <a:ext uri="{C572A759-6A51-4108-AA02-DFA0A04FC94B}">
+              <ma14:wrappingTextBoxFlag xmlns:ma14="http://schemas.microsoft.com/office/mac/drawingml/2011/main" val="0"/>
+            </a:ext>
+          </a:extLst>
+        </p:spPr>
+        <p:txBody>
+          <a:bodyPr/>
+          <a:lstStyle>
+            <a:lvl1pPr>
+              <a:defRPr sz="1000">
+                <a:solidFill>
+                  <a:srgbClr val="8A949B"/>
+                </a:solidFill>
+              </a:defRPr>
+            </a:lvl1pPr>
+          </a:lstStyle>
+          <a:p>
+            <a:pPr algn="r"/>
+            <a:fld id="{F7021451-1387-4CA6-816F-3879F97B5CBC}" type="slidenum">
+              <a:rPr b="0" lang="en-US"/>
+              <a:t>11</a:t>
+            </a:fld>
+            <a:endParaRPr lang="en-US"/>
+          </a:p>
+        </p:txBody>
+      </p:sp>
+    </p:spTree>
+  </p:cSld>
+  <p:clrMapOvr>
+    <a:masterClrMapping/>
+  </p:clrMapOvr>
+</p:sld>
+</file>
+
+<file path=ppt/slides/slide16.xml><?xml version="1.0" encoding="utf-8"?>
+<p:sld xmlns:a="http://schemas.openxmlformats.org/drawingml/2006/main" xmlns:p="http://schemas.openxmlformats.org/presentationml/2006/main" xmlns:r="http://schemas.openxmlformats.org/officeDocument/2006/relationships">
+  <p:cSld>
+    <p:spTree>
+      <p:nvGrpSpPr>
+        <p:cNvPr id="1" name=""/>
+        <p:cNvGrpSpPr/>
+        <p:nvPr/>
+      </p:nvGrpSpPr>
+      <p:grpSpPr/>
+      <p:sp>
+        <p:nvSpPr>
+          <p:cNvPr id="2" name="Text 0"/>
+          <p:cNvSpPr/>
+          <p:nvPr>
+            <p:ph idx="100" type="title" hasCustomPrompt="1"/>
+          </p:nvPr>
+        </p:nvSpPr>
+        <p:spPr>
+          <a:xfrm>
+            <a:off x="548640" y="365760"/>
+            <a:ext cx="11064240" cy="822960"/>
+          </a:xfrm>
+          <a:prstGeom prst="rect">
+            <a:avLst/>
+          </a:prstGeom>
+          <a:noFill/>
+          <a:ln/>
+        </p:spPr>
+        <p:txBody>
+          <a:bodyPr wrap="square" lIns="0" tIns="0" rIns="0" bIns="0" rtlCol="0" anchor="ctr"/>
+          <a:lstStyle/>
+          <a:p>
+            <a:pPr algn="l" indent="0" marL="0">
+              <a:buNone/>
+            </a:pPr>
+            <a:r>
+              <a:rPr lang="en-US" sz="3400" b="1" dirty="0">
+                <a:solidFill>
+                  <a:schemeClr val="tx2"/>
+                </a:solidFill>
+              </a:rPr>
+              <a:t>Results: baseline vs proposed (mean ± SD, 10 seeds)</a:t>
+            </a:r>
+            <a:endParaRPr lang="en-US" sz="3400" dirty="0"/>
+          </a:p>
+        </p:txBody>
+      </p:sp>
+      <p:sp>
+        <p:nvSpPr>
+          <p:cNvPr id="25" name="Slide Number Placeholder 0"/>
+          <p:cNvSpPr>
+            <a:spLocks noGrp="1"/>
+          </p:cNvSpPr>
+          <p:nvPr>
+            <p:ph type="sldNum" sz="quarter" idx="4294967295"/>
+          </p:nvPr>
+        </p:nvSpPr>
+        <p:spPr>
+          <a:xfrm>
+            <a:off x="11247120" y="6400800"/>
+            <a:ext cx="548640" cy="274320"/>
+          </a:xfrm>
+          <a:prstGeom prst="rect">
+            <a:avLst/>
+          </a:prstGeom>
+          <a:extLst>
+            <a:ext uri="{C572A759-6A51-4108-AA02-DFA0A04FC94B}">
+              <ma14:wrappingTextBoxFlag xmlns:ma14="http://schemas.microsoft.com/office/mac/drawingml/2011/main" val="0"/>
+            </a:ext>
+          </a:extLst>
+        </p:spPr>
+        <p:txBody>
+          <a:bodyPr/>
+          <a:lstStyle>
+            <a:lvl1pPr>
+              <a:defRPr sz="1000">
+                <a:solidFill>
+                  <a:srgbClr val="8A949B"/>
+                </a:solidFill>
+              </a:defRPr>
+            </a:lvl1pPr>
+          </a:lstStyle>
+          <a:p>
+            <a:pPr algn="r"/>
+            <a:fld id="{F7021451-1387-4CA6-816F-3879F97B5CBC}" type="slidenum">
+              <a:rPr b="0" lang="en-US"/>
+              <a:t>8</a:t>
+            </a:fld>
+            <a:endParaRPr lang="en-US"/>
+          </a:p>
+        </p:txBody>
+      </p:sp>
+      <p:graphicFrame>
+        <p:nvGraphicFramePr>
+          <p:cNvPr id="26" name="Table 25"/>
+          <p:cNvGraphicFramePr>
+            <a:graphicFrameLocks noGrp="1"/>
+          </p:cNvGraphicFramePr>
+          <p:nvPr/>
+        </p:nvGraphicFramePr>
+        <p:xfrm>
+          <a:off x="548640" y="1371600"/>
+          <a:ext cx="11064240" cy="4114800"/>
+        </p:xfrm>
+        <a:graphic>
+          <a:graphicData uri="http://schemas.openxmlformats.org/drawingml/2006/table">
+            <a:tbl>
+              <a:tblPr firstRow="1" bandRow="1"/>
+              <a:tblGrid>
+                <a:gridCol w="3017520"/>
+                <a:gridCol w="2560320"/>
+                <a:gridCol w="2011680"/>
+                <a:gridCol w="2011680"/>
+                <a:gridCol w="1463040"/>
+              </a:tblGrid>
+              <a:tr h="457200">
+                <a:tc>
+                  <a:txBody>
+                    <a:bodyPr/>
+                    <a:lstStyle/>
+                    <a:p>
+                      <a:pPr algn="l"/>
+                      <a:r>
+                        <a:rPr sz="1500" b="1">
+                          <a:solidFill>
+                            <a:srgbClr val="FFFFFF"/>
+                          </a:solidFill>
+                        </a:rPr>
+                        <a:t>Scenario</a:t>
+                      </a:r>
+                    </a:p>
+                  </a:txBody>
+                  <a:tcPr anchor="ctr" marL="91440" marR="91440">
+                    <a:solidFill>
+                      <a:srgbClr val="123A40"/>
+                    </a:solidFill>
+                  </a:tcPr>
+                </a:tc>
+                <a:tc>
+                  <a:txBody>
+                    <a:bodyPr/>
+                    <a:lstStyle/>
+                    <a:p>
+                      <a:pPr algn="l"/>
+                      <a:r>
+                        <a:rPr sz="1500" b="1">
+                          <a:solidFill>
+                            <a:srgbClr val="FFFFFF"/>
+                          </a:solidFill>
+                        </a:rPr>
+                        <a:t>Metric</a:t>
+                      </a:r>
+                    </a:p>
+                  </a:txBody>
+                  <a:tcPr anchor="ctr" marL="91440" marR="91440">
+                    <a:solidFill>
+                      <a:srgbClr val="123A40"/>
+                    </a:solidFill>
+                  </a:tcPr>
+                </a:tc>
+                <a:tc>
+                  <a:txBody>
+                    <a:bodyPr/>
+                    <a:lstStyle/>
+                    <a:p>
+                      <a:pPr algn="ctr"/>
+                      <a:r>
+                        <a:rPr sz="1500" b="1">
+                          <a:solidFill>
+                            <a:srgbClr val="FFFFFF"/>
+                          </a:solidFill>
+                        </a:rPr>
+                        <a:t>OSPF-like (baseline)</a:t>
+                      </a:r>
+                    </a:p>
+                  </a:txBody>
+                  <a:tcPr anchor="ctr" marL="91440" marR="91440">
+                    <a:solidFill>
+                      <a:srgbClr val="123A40"/>
+                    </a:solidFill>
+                  </a:tcPr>
+                </a:tc>
+                <a:tc>
+                  <a:txBody>
+                    <a:bodyPr/>
+                    <a:lstStyle/>
+                    <a:p>
+                      <a:pPr algn="ctr"/>
+                      <a:r>
+                        <a:rPr sz="1500" b="1">
+                          <a:solidFill>
+                            <a:srgbClr val="FFFFFF"/>
+                          </a:solidFill>
+                        </a:rPr>
+                        <a:t>IRP (proposed)</a:t>
+                      </a:r>
+                    </a:p>
+                  </a:txBody>
+                  <a:tcPr anchor="ctr" marL="91440" marR="91440">
+                    <a:solidFill>
+                      <a:srgbClr val="123A40"/>
+                    </a:solidFill>
+                  </a:tcPr>
+                </a:tc>
+                <a:tc>
+                  <a:txBody>
+                    <a:bodyPr/>
+                    <a:lstStyle/>
+                    <a:p>
+                      <a:pPr algn="ctr"/>
+                      <a:r>
+                        <a:rPr sz="1500" b="1">
+                          <a:solidFill>
+                            <a:srgbClr val="FFFFFF"/>
+                          </a:solidFill>
+                        </a:rPr>
+                        <a:t>Improvement</a:t>
+                      </a:r>
+                    </a:p>
+                  </a:txBody>
+                  <a:tcPr anchor="ctr" marL="91440" marR="91440">
+                    <a:solidFill>
+                      <a:srgbClr val="123A40"/>
+                    </a:solidFill>
+                  </a:tcPr>
+                </a:tc>
+              </a:tr>
+              <a:tr h="457200">
+                <a:tc>
+                  <a:txBody>
+                    <a:bodyPr/>
+                    <a:lstStyle/>
+                    <a:p>
+                      <a:pPr algn="l"/>
+                      <a:r>
+                        <a:rPr sz="1500" b="0">
+                          <a:solidFill>
+                            <a:srgbClr val="1A1F24"/>
+                          </a:solidFill>
+                        </a:rPr>
+                        <a:t>Bandwidth drop</a:t>
+                      </a:r>
+                    </a:p>
+                  </a:txBody>
+                  <a:tcPr anchor="ctr" marL="91440" marR="91440">
+                    <a:solidFill>
+                      <a:srgbClr val="EEF4F3"/>
+                    </a:solidFill>
+                  </a:tcPr>
+                </a:tc>
+                <a:tc>
+                  <a:txBody>
+                    <a:bodyPr/>
+                    <a:lstStyle/>
+                    <a:p>
+                      <a:pPr algn="l"/>
+                      <a:r>
+                        <a:rPr sz="1500" b="0">
+                          <a:solidFill>
+                            <a:srgbClr val="1A1F24"/>
+                          </a:solidFill>
+                        </a:rPr>
+                        <a:t>Delivery ratio</a:t>
+                      </a:r>
+                    </a:p>
+                  </a:txBody>
+                  <a:tcPr anchor="ctr" marL="91440" marR="91440">
+                    <a:solidFill>
+                      <a:srgbClr val="EEF4F3"/>
+                    </a:solidFill>
+                  </a:tcPr>
+                </a:tc>
+                <a:tc>
+                  <a:txBody>
+                    <a:bodyPr/>
+                    <a:lstStyle/>
+                    <a:p>
+                      <a:pPr algn="ctr"/>
+                      <a:r>
+                        <a:rPr sz="1500" b="0">
+                          <a:solidFill>
+                            <a:srgbClr val="1A1F24"/>
+                          </a:solidFill>
+                        </a:rPr>
+                        <a:t>0.867 ± 0.001</a:t>
+                      </a:r>
+                    </a:p>
+                  </a:txBody>
+                  <a:tcPr anchor="ctr" marL="91440" marR="91440">
+                    <a:solidFill>
+                      <a:srgbClr val="EEF4F3"/>
+                    </a:solidFill>
+                  </a:tcPr>
+                </a:tc>
+                <a:tc>
+                  <a:txBody>
+                    <a:bodyPr/>
+                    <a:lstStyle/>
+                    <a:p>
+                      <a:pPr algn="ctr"/>
+                      <a:r>
+                        <a:rPr sz="1500" b="1">
+                          <a:solidFill>
+                            <a:srgbClr val="1A1F24"/>
+                          </a:solidFill>
+                        </a:rPr>
+                        <a:t>0.996 ± 0.001</a:t>
+                      </a:r>
+                    </a:p>
+                  </a:txBody>
+                  <a:tcPr anchor="ctr" marL="91440" marR="91440">
+                    <a:solidFill>
+                      <a:srgbClr val="EEF4F3"/>
+                    </a:solidFill>
+                  </a:tcPr>
+                </a:tc>
+                <a:tc>
+                  <a:txBody>
+                    <a:bodyPr/>
+                    <a:lstStyle/>
+                    <a:p>
+                      <a:pPr algn="ctr"/>
+                      <a:r>
+                        <a:rPr sz="1500" b="1">
+                          <a:solidFill>
+                            <a:srgbClr val="0E8C7F"/>
+                          </a:solidFill>
+                        </a:rPr>
+                        <a:t>+14.9 %</a:t>
+                      </a:r>
+                    </a:p>
+                  </a:txBody>
+                  <a:tcPr anchor="ctr" marL="91440" marR="91440">
+                    <a:solidFill>
+                      <a:srgbClr val="EEF4F3"/>
+                    </a:solidFill>
+                  </a:tcPr>
+                </a:tc>
+              </a:tr>
+              <a:tr h="457200">
+                <a:tc>
+                  <a:txBody>
+                    <a:bodyPr/>
+                    <a:lstStyle/>
+                    <a:p>
+                      <a:pPr algn="l"/>
+                      <a:r>
+                        <a:rPr sz="1500" b="0">
+                          <a:solidFill>
+                            <a:srgbClr val="1A1F24"/>
+                          </a:solidFill>
+                        </a:rPr>
+                        <a:t>Packet loss increase</a:t>
+                      </a:r>
+                    </a:p>
+                  </a:txBody>
+                  <a:tcPr anchor="ctr" marL="91440" marR="91440">
+                    <a:noFill/>
+                  </a:tcPr>
+                </a:tc>
+                <a:tc>
+                  <a:txBody>
+                    <a:bodyPr/>
+                    <a:lstStyle/>
+                    <a:p>
+                      <a:pPr algn="l"/>
+                      <a:r>
+                        <a:rPr sz="1500" b="0">
+                          <a:solidFill>
+                            <a:srgbClr val="1A1F24"/>
+                          </a:solidFill>
+                        </a:rPr>
+                        <a:t>Time degraded (s)</a:t>
+                      </a:r>
+                    </a:p>
+                  </a:txBody>
+                  <a:tcPr anchor="ctr" marL="91440" marR="91440">
+                    <a:noFill/>
+                  </a:tcPr>
+                </a:tc>
+                <a:tc>
+                  <a:txBody>
+                    <a:bodyPr/>
+                    <a:lstStyle/>
+                    <a:p>
+                      <a:pPr algn="ctr"/>
+                      <a:r>
+                        <a:rPr sz="1500" b="0">
+                          <a:solidFill>
+                            <a:srgbClr val="1A1F24"/>
+                          </a:solidFill>
+                        </a:rPr>
+                        <a:t>23.58 ± 0.48</a:t>
+                      </a:r>
+                    </a:p>
+                  </a:txBody>
+                  <a:tcPr anchor="ctr" marL="91440" marR="91440">
+                    <a:noFill/>
+                  </a:tcPr>
+                </a:tc>
+                <a:tc>
+                  <a:txBody>
+                    <a:bodyPr/>
+                    <a:lstStyle/>
+                    <a:p>
+                      <a:pPr algn="ctr"/>
+                      <a:r>
+                        <a:rPr sz="1500" b="1">
+                          <a:solidFill>
+                            <a:srgbClr val="1A1F24"/>
+                          </a:solidFill>
+                        </a:rPr>
+                        <a:t>0.10 ± 0.23</a:t>
+                      </a:r>
+                    </a:p>
+                  </a:txBody>
+                  <a:tcPr anchor="ctr" marL="91440" marR="91440">
+                    <a:noFill/>
+                  </a:tcPr>
+                </a:tc>
+                <a:tc>
+                  <a:txBody>
+                    <a:bodyPr/>
+                    <a:lstStyle/>
+                    <a:p>
+                      <a:pPr algn="ctr"/>
+                      <a:r>
+                        <a:rPr sz="1500" b="1">
+                          <a:solidFill>
+                            <a:srgbClr val="0E8C7F"/>
+                          </a:solidFill>
+                        </a:rPr>
+                        <a:t>+99.6 %</a:t>
+                      </a:r>
+                    </a:p>
+                  </a:txBody>
+                  <a:tcPr anchor="ctr" marL="91440" marR="91440">
+                    <a:noFill/>
+                  </a:tcPr>
+                </a:tc>
+              </a:tr>
+              <a:tr h="457200">
+                <a:tc>
+                  <a:txBody>
+                    <a:bodyPr/>
+                    <a:lstStyle/>
+                    <a:p>
+                      <a:pPr algn="l"/>
+                      <a:r>
+                        <a:rPr sz="1500" b="0">
+                          <a:solidFill>
+                            <a:srgbClr val="1A1F24"/>
+                          </a:solidFill>
+                        </a:rPr>
+                        <a:t>Link failure</a:t>
+                      </a:r>
+                    </a:p>
+                  </a:txBody>
+                  <a:tcPr anchor="ctr" marL="91440" marR="91440">
+                    <a:solidFill>
+                      <a:srgbClr val="EEF4F3"/>
+                    </a:solidFill>
+                  </a:tcPr>
+                </a:tc>
+                <a:tc>
+                  <a:txBody>
+                    <a:bodyPr/>
+                    <a:lstStyle/>
+                    <a:p>
+                      <a:pPr algn="l"/>
+                      <a:r>
+                        <a:rPr sz="1500" b="0">
+                          <a:solidFill>
+                            <a:srgbClr val="1A1F24"/>
+                          </a:solidFill>
+                        </a:rPr>
+                        <a:t>Recovery time (s)</a:t>
+                      </a:r>
+                    </a:p>
+                  </a:txBody>
+                  <a:tcPr anchor="ctr" marL="91440" marR="91440">
+                    <a:solidFill>
+                      <a:srgbClr val="EEF4F3"/>
+                    </a:solidFill>
+                  </a:tcPr>
+                </a:tc>
+                <a:tc>
+                  <a:txBody>
+                    <a:bodyPr/>
+                    <a:lstStyle/>
+                    <a:p>
+                      <a:pPr algn="ctr"/>
+                      <a:r>
+                        <a:rPr sz="1500" b="0">
+                          <a:solidFill>
+                            <a:srgbClr val="1A1F24"/>
+                          </a:solidFill>
+                        </a:rPr>
+                        <a:t>1.15 ± 0.15</a:t>
+                      </a:r>
+                    </a:p>
+                  </a:txBody>
+                  <a:tcPr anchor="ctr" marL="91440" marR="91440">
+                    <a:solidFill>
+                      <a:srgbClr val="EEF4F3"/>
+                    </a:solidFill>
+                  </a:tcPr>
+                </a:tc>
+                <a:tc>
+                  <a:txBody>
+                    <a:bodyPr/>
+                    <a:lstStyle/>
+                    <a:p>
+                      <a:pPr algn="ctr"/>
+                      <a:r>
+                        <a:rPr sz="1500" b="1">
+                          <a:solidFill>
+                            <a:srgbClr val="1A1F24"/>
+                          </a:solidFill>
+                        </a:rPr>
+                        <a:t>0.13 ± 0.14</a:t>
+                      </a:r>
+                    </a:p>
+                  </a:txBody>
+                  <a:tcPr anchor="ctr" marL="91440" marR="91440">
+                    <a:solidFill>
+                      <a:srgbClr val="EEF4F3"/>
+                    </a:solidFill>
+                  </a:tcPr>
+                </a:tc>
+                <a:tc>
+                  <a:txBody>
+                    <a:bodyPr/>
+                    <a:lstStyle/>
+                    <a:p>
+                      <a:pPr algn="ctr"/>
+                      <a:r>
+                        <a:rPr sz="1500" b="1">
+                          <a:solidFill>
+                            <a:srgbClr val="0E8C7F"/>
+                          </a:solidFill>
+                        </a:rPr>
+                        <a:t>+88.7 %</a:t>
+                      </a:r>
+                    </a:p>
+                  </a:txBody>
+                  <a:tcPr anchor="ctr" marL="91440" marR="91440">
+                    <a:solidFill>
+                      <a:srgbClr val="EEF4F3"/>
+                    </a:solidFill>
+                  </a:tcPr>
+                </a:tc>
+              </a:tr>
+              <a:tr h="457200">
+                <a:tc>
+                  <a:txBody>
+                    <a:bodyPr/>
+                    <a:lstStyle/>
+                    <a:p>
+                      <a:pPr algn="l"/>
+                      <a:r>
+                        <a:rPr sz="1500" b="0">
+                          <a:solidFill>
+                            <a:srgbClr val="1A1F24"/>
+                          </a:solidFill>
+                        </a:rPr>
+                        <a:t>Congestion build-up</a:t>
+                      </a:r>
+                    </a:p>
+                  </a:txBody>
+                  <a:tcPr anchor="ctr" marL="91440" marR="91440">
+                    <a:noFill/>
+                  </a:tcPr>
+                </a:tc>
+                <a:tc>
+                  <a:txBody>
+                    <a:bodyPr/>
+                    <a:lstStyle/>
+                    <a:p>
+                      <a:pPr algn="l"/>
+                      <a:r>
+                        <a:rPr sz="1500" b="0">
+                          <a:solidFill>
+                            <a:srgbClr val="1A1F24"/>
+                          </a:solidFill>
+                        </a:rPr>
+                        <a:t>Mean latency (ms)</a:t>
+                      </a:r>
+                    </a:p>
+                  </a:txBody>
+                  <a:tcPr anchor="ctr" marL="91440" marR="91440">
+                    <a:noFill/>
+                  </a:tcPr>
+                </a:tc>
+                <a:tc>
+                  <a:txBody>
+                    <a:bodyPr/>
+                    <a:lstStyle/>
+                    <a:p>
+                      <a:pPr algn="ctr"/>
+                      <a:r>
+                        <a:rPr sz="1500" b="0">
+                          <a:solidFill>
+                            <a:srgbClr val="1A1F24"/>
+                          </a:solidFill>
+                        </a:rPr>
+                        <a:t>57.2 ± 0.1</a:t>
+                      </a:r>
+                    </a:p>
+                  </a:txBody>
+                  <a:tcPr anchor="ctr" marL="91440" marR="91440">
+                    <a:noFill/>
+                  </a:tcPr>
+                </a:tc>
+                <a:tc>
+                  <a:txBody>
+                    <a:bodyPr/>
+                    <a:lstStyle/>
+                    <a:p>
+                      <a:pPr algn="ctr"/>
+                      <a:r>
+                        <a:rPr sz="1500" b="1">
+                          <a:solidFill>
+                            <a:srgbClr val="1A1F24"/>
+                          </a:solidFill>
+                        </a:rPr>
+                        <a:t>23.9 ± 0.3</a:t>
+                      </a:r>
+                    </a:p>
+                  </a:txBody>
+                  <a:tcPr anchor="ctr" marL="91440" marR="91440">
+                    <a:noFill/>
+                  </a:tcPr>
+                </a:tc>
+                <a:tc>
+                  <a:txBody>
+                    <a:bodyPr/>
+                    <a:lstStyle/>
+                    <a:p>
+                      <a:pPr algn="ctr"/>
+                      <a:r>
+                        <a:rPr sz="1500" b="1">
+                          <a:solidFill>
+                            <a:srgbClr val="0E8C7F"/>
+                          </a:solidFill>
+                        </a:rPr>
+                        <a:t>+58.2 %</a:t>
+                      </a:r>
+                    </a:p>
+                  </a:txBody>
+                  <a:tcPr anchor="ctr" marL="91440" marR="91440">
+                    <a:noFill/>
+                  </a:tcPr>
+                </a:tc>
+              </a:tr>
+              <a:tr h="457200">
+                <a:tc>
+                  <a:txBody>
+                    <a:bodyPr/>
+                    <a:lstStyle/>
+                    <a:p>
+                      <a:pPr algn="l"/>
+                      <a:r>
+                        <a:rPr sz="1500" b="0">
+                          <a:solidFill>
+                            <a:srgbClr val="1A1F24"/>
+                          </a:solidFill>
+                        </a:rPr>
+                        <a:t>Flapping link</a:t>
+                      </a:r>
+                    </a:p>
+                  </a:txBody>
+                  <a:tcPr anchor="ctr" marL="91440" marR="91440">
+                    <a:solidFill>
+                      <a:srgbClr val="EEF4F3"/>
+                    </a:solidFill>
+                  </a:tcPr>
+                </a:tc>
+                <a:tc>
+                  <a:txBody>
+                    <a:bodyPr/>
+                    <a:lstStyle/>
+                    <a:p>
+                      <a:pPr algn="l"/>
+                      <a:r>
+                        <a:rPr sz="1500" b="0">
+                          <a:solidFill>
+                            <a:srgbClr val="1A1F24"/>
+                          </a:solidFill>
+                        </a:rPr>
+                        <a:t>Route changes</a:t>
+                      </a:r>
+                    </a:p>
+                  </a:txBody>
+                  <a:tcPr anchor="ctr" marL="91440" marR="91440">
+                    <a:solidFill>
+                      <a:srgbClr val="EEF4F3"/>
+                    </a:solidFill>
+                  </a:tcPr>
+                </a:tc>
+                <a:tc>
+                  <a:txBody>
+                    <a:bodyPr/>
+                    <a:lstStyle/>
+                    <a:p>
+                      <a:pPr algn="ctr"/>
+                      <a:r>
+                        <a:rPr sz="1500" b="0">
+                          <a:solidFill>
+                            <a:srgbClr val="1A1F24"/>
+                          </a:solidFill>
+                        </a:rPr>
+                        <a:t>12.0 ± 0.0</a:t>
+                      </a:r>
+                    </a:p>
+                  </a:txBody>
+                  <a:tcPr anchor="ctr" marL="91440" marR="91440">
+                    <a:solidFill>
+                      <a:srgbClr val="EEF4F3"/>
+                    </a:solidFill>
+                  </a:tcPr>
+                </a:tc>
+                <a:tc>
+                  <a:txBody>
+                    <a:bodyPr/>
+                    <a:lstStyle/>
+                    <a:p>
+                      <a:pPr algn="ctr"/>
+                      <a:r>
+                        <a:rPr sz="1500" b="1">
+                          <a:solidFill>
+                            <a:srgbClr val="1A1F24"/>
+                          </a:solidFill>
+                        </a:rPr>
+                        <a:t>2.0 ± 0.0</a:t>
+                      </a:r>
+                    </a:p>
+                  </a:txBody>
+                  <a:tcPr anchor="ctr" marL="91440" marR="91440">
+                    <a:solidFill>
+                      <a:srgbClr val="EEF4F3"/>
+                    </a:solidFill>
+                  </a:tcPr>
+                </a:tc>
+                <a:tc>
+                  <a:txBody>
+                    <a:bodyPr/>
+                    <a:lstStyle/>
+                    <a:p>
+                      <a:pPr algn="ctr"/>
+                      <a:r>
+                        <a:rPr sz="1500" b="1">
+                          <a:solidFill>
+                            <a:srgbClr val="0E8C7F"/>
+                          </a:solidFill>
+                        </a:rPr>
+                        <a:t>+83.3 %</a:t>
+                      </a:r>
+                    </a:p>
+                  </a:txBody>
+                  <a:tcPr anchor="ctr" marL="91440" marR="91440">
+                    <a:solidFill>
+                      <a:srgbClr val="EEF4F3"/>
+                    </a:solidFill>
+                  </a:tcPr>
+                </a:tc>
+              </a:tr>
+              <a:tr h="457200">
+                <a:tc>
+                  <a:txBody>
+                    <a:bodyPr/>
+                    <a:lstStyle/>
+                    <a:p>
+                      <a:pPr algn="l"/>
+                      <a:r>
+                        <a:rPr sz="1500" b="0">
+                          <a:solidFill>
+                            <a:srgbClr val="1A1F24"/>
+                          </a:solidFill>
+                        </a:rPr>
+                        <a:t>Lossy shortcut</a:t>
+                      </a:r>
+                    </a:p>
+                  </a:txBody>
+                  <a:tcPr anchor="ctr" marL="91440" marR="91440">
+                    <a:noFill/>
+                  </a:tcPr>
+                </a:tc>
+                <a:tc>
+                  <a:txBody>
+                    <a:bodyPr/>
+                    <a:lstStyle/>
+                    <a:p>
+                      <a:pPr algn="l"/>
+                      <a:r>
+                        <a:rPr sz="1500" b="0">
+                          <a:solidFill>
+                            <a:srgbClr val="1A1F24"/>
+                          </a:solidFill>
+                        </a:rPr>
+                        <a:t>Delivery ratio</a:t>
+                      </a:r>
+                    </a:p>
+                  </a:txBody>
+                  <a:tcPr anchor="ctr" marL="91440" marR="91440">
+                    <a:noFill/>
+                  </a:tcPr>
+                </a:tc>
+                <a:tc>
+                  <a:txBody>
+                    <a:bodyPr/>
+                    <a:lstStyle/>
+                    <a:p>
+                      <a:pPr algn="ctr"/>
+                      <a:r>
+                        <a:rPr sz="1500" b="0">
+                          <a:solidFill>
+                            <a:srgbClr val="1A1F24"/>
+                          </a:solidFill>
+                        </a:rPr>
+                        <a:t>0.924 ± 0.001</a:t>
+                      </a:r>
+                    </a:p>
+                  </a:txBody>
+                  <a:tcPr anchor="ctr" marL="91440" marR="91440">
+                    <a:noFill/>
+                  </a:tcPr>
+                </a:tc>
+                <a:tc>
+                  <a:txBody>
+                    <a:bodyPr/>
+                    <a:lstStyle/>
+                    <a:p>
+                      <a:pPr algn="ctr"/>
+                      <a:r>
+                        <a:rPr sz="1500" b="1">
+                          <a:solidFill>
+                            <a:srgbClr val="1A1F24"/>
+                          </a:solidFill>
+                        </a:rPr>
+                        <a:t>0.994 ± 0.000</a:t>
+                      </a:r>
+                    </a:p>
+                  </a:txBody>
+                  <a:tcPr anchor="ctr" marL="91440" marR="91440">
+                    <a:noFill/>
+                  </a:tcPr>
+                </a:tc>
+                <a:tc>
+                  <a:txBody>
+                    <a:bodyPr/>
+                    <a:lstStyle/>
+                    <a:p>
+                      <a:pPr algn="ctr"/>
+                      <a:r>
+                        <a:rPr sz="1500" b="1">
+                          <a:solidFill>
+                            <a:srgbClr val="0E8C7F"/>
+                          </a:solidFill>
+                        </a:rPr>
+                        <a:t>+7.6 %</a:t>
+                      </a:r>
+                    </a:p>
+                  </a:txBody>
+                  <a:tcPr anchor="ctr" marL="91440" marR="91440">
+                    <a:noFill/>
+                  </a:tcPr>
+                </a:tc>
+              </a:tr>
+              <a:tr h="457200">
+                <a:tc>
+                  <a:txBody>
+                    <a:bodyPr/>
+                    <a:lstStyle/>
+                    <a:p>
+                      <a:pPr algn="l"/>
+                      <a:r>
+                        <a:rPr sz="1500" b="0">
+                          <a:solidFill>
+                            <a:srgbClr val="1A1F24"/>
+                          </a:solidFill>
+                        </a:rPr>
+                        <a:t>Steady state</a:t>
+                      </a:r>
+                    </a:p>
+                  </a:txBody>
+                  <a:tcPr anchor="ctr" marL="91440" marR="91440">
+                    <a:solidFill>
+                      <a:srgbClr val="EEF4F3"/>
+                    </a:solidFill>
+                  </a:tcPr>
+                </a:tc>
+                <a:tc>
+                  <a:txBody>
+                    <a:bodyPr/>
+                    <a:lstStyle/>
+                    <a:p>
+                      <a:pPr algn="l"/>
+                      <a:r>
+                        <a:rPr sz="1500" b="0">
+                          <a:solidFill>
+                            <a:srgbClr val="1A1F24"/>
+                          </a:solidFill>
+                        </a:rPr>
+                        <a:t>Delivery ratio</a:t>
+                      </a:r>
+                    </a:p>
+                  </a:txBody>
+                  <a:tcPr anchor="ctr" marL="91440" marR="91440">
+                    <a:solidFill>
+                      <a:srgbClr val="EEF4F3"/>
+                    </a:solidFill>
+                  </a:tcPr>
+                </a:tc>
+                <a:tc>
+                  <a:txBody>
+                    <a:bodyPr/>
+                    <a:lstStyle/>
+                    <a:p>
+                      <a:pPr algn="ctr"/>
+                      <a:r>
+                        <a:rPr sz="1500" b="0">
+                          <a:solidFill>
+                            <a:srgbClr val="1A1F24"/>
+                          </a:solidFill>
+                        </a:rPr>
+                        <a:t>0.997 ± 0.000</a:t>
+                      </a:r>
+                    </a:p>
+                  </a:txBody>
+                  <a:tcPr anchor="ctr" marL="91440" marR="91440">
+                    <a:solidFill>
+                      <a:srgbClr val="EEF4F3"/>
+                    </a:solidFill>
+                  </a:tcPr>
+                </a:tc>
+                <a:tc>
+                  <a:txBody>
+                    <a:bodyPr/>
+                    <a:lstStyle/>
+                    <a:p>
+                      <a:pPr algn="ctr"/>
+                      <a:r>
+                        <a:rPr sz="1500" b="1">
+                          <a:solidFill>
+                            <a:srgbClr val="1A1F24"/>
+                          </a:solidFill>
+                        </a:rPr>
+                        <a:t>0.997 ± 0.000</a:t>
+                      </a:r>
+                    </a:p>
+                  </a:txBody>
+                  <a:tcPr anchor="ctr" marL="91440" marR="91440">
+                    <a:solidFill>
+                      <a:srgbClr val="EEF4F3"/>
+                    </a:solidFill>
+                  </a:tcPr>
+                </a:tc>
+                <a:tc>
+                  <a:txBody>
+                    <a:bodyPr/>
+                    <a:lstStyle/>
+                    <a:p>
+                      <a:pPr algn="ctr"/>
+                      <a:r>
+                        <a:rPr sz="1500" b="1">
+                          <a:solidFill>
+                            <a:srgbClr val="0E8C7F"/>
+                          </a:solidFill>
+                        </a:rPr>
+                        <a:t>same</a:t>
+                      </a:r>
+                    </a:p>
+                  </a:txBody>
+                  <a:tcPr anchor="ctr" marL="91440" marR="91440">
+                    <a:solidFill>
+                      <a:srgbClr val="EEF4F3"/>
+                    </a:solidFill>
+                  </a:tcPr>
+                </a:tc>
+              </a:tr>
+              <a:tr h="457200">
+                <a:tc>
+                  <a:txBody>
+                    <a:bodyPr/>
+                    <a:lstStyle/>
+                    <a:p>
+                      <a:pPr algn="l"/>
+                      <a:r>
+                        <a:rPr sz="1500" b="0">
+                          <a:solidFill>
+                            <a:srgbClr val="1A1F24"/>
+                          </a:solidFill>
+                        </a:rPr>
+                        <a:t>Packet loss increase</a:t>
+                      </a:r>
+                    </a:p>
+                  </a:txBody>
+                  <a:tcPr anchor="ctr" marL="91440" marR="91440">
+                    <a:noFill/>
+                  </a:tcPr>
+                </a:tc>
+                <a:tc>
+                  <a:txBody>
+                    <a:bodyPr/>
+                    <a:lstStyle/>
+                    <a:p>
+                      <a:pPr algn="l"/>
+                      <a:r>
+                        <a:rPr sz="1500" b="0">
+                          <a:solidFill>
+                            <a:srgbClr val="1A1F24"/>
+                          </a:solidFill>
+                        </a:rPr>
+                        <a:t>Mean latency (ms)</a:t>
+                      </a:r>
+                    </a:p>
+                  </a:txBody>
+                  <a:tcPr anchor="ctr" marL="91440" marR="91440">
+                    <a:noFill/>
+                  </a:tcPr>
+                </a:tc>
+                <a:tc>
+                  <a:txBody>
+                    <a:bodyPr/>
+                    <a:lstStyle/>
+                    <a:p>
+                      <a:pPr algn="ctr"/>
+                      <a:r>
+                        <a:rPr sz="1500" b="0">
+                          <a:solidFill>
+                            <a:srgbClr val="1A1F24"/>
+                          </a:solidFill>
+                        </a:rPr>
+                        <a:t>20.1 ± 0.0</a:t>
+                      </a:r>
+                    </a:p>
+                  </a:txBody>
+                  <a:tcPr anchor="ctr" marL="91440" marR="91440">
+                    <a:noFill/>
+                  </a:tcPr>
+                </a:tc>
+                <a:tc>
+                  <a:txBody>
+                    <a:bodyPr/>
+                    <a:lstStyle/>
+                    <a:p>
+                      <a:pPr algn="ctr"/>
+                      <a:r>
+                        <a:rPr sz="1500" b="1">
+                          <a:solidFill>
+                            <a:srgbClr val="1A1F24"/>
+                          </a:solidFill>
+                        </a:rPr>
+                        <a:t>23.6 ± 0.2</a:t>
+                      </a:r>
+                    </a:p>
+                  </a:txBody>
+                  <a:tcPr anchor="ctr" marL="91440" marR="91440">
+                    <a:noFill/>
+                  </a:tcPr>
+                </a:tc>
+                <a:tc>
+                  <a:txBody>
+                    <a:bodyPr/>
+                    <a:lstStyle/>
+                    <a:p>
+                      <a:pPr algn="ctr"/>
+                      <a:r>
+                        <a:rPr sz="1500" b="1">
+                          <a:solidFill>
+                            <a:srgbClr val="C0501E"/>
+                          </a:solidFill>
+                        </a:rPr>
+                        <a:t>-17.1 %</a:t>
+                      </a:r>
+                    </a:p>
+                  </a:txBody>
+                  <a:tcPr anchor="ctr" marL="91440" marR="91440">
+                    <a:noFill/>
+                  </a:tcPr>
+                </a:tc>
+              </a:tr>
+            </a:tbl>
+          </a:graphicData>
+        </a:graphic>
+      </p:graphicFrame>
+      <p:sp>
+        <p:nvSpPr>
+          <p:cNvPr id="27" name="TextBox 26"/>
+          <p:cNvSpPr txBox="1"/>
+          <p:nvPr/>
+        </p:nvSpPr>
+        <p:spPr>
+          <a:xfrm>
+            <a:off x="548640" y="5669280"/>
+            <a:ext cx="11064240" cy="640080"/>
+          </a:xfrm>
+          <a:prstGeom prst="rect">
+            <a:avLst/>
+          </a:prstGeom>
+          <a:noFill/>
+        </p:spPr>
+        <p:txBody>
+          <a:bodyPr wrap="square">
+            <a:spAutoFit/>
+          </a:bodyPr>
+          <a:lstStyle/>
+          <a:p>
+            <a:r>
+              <a:rPr sz="1400">
+                <a:solidFill>
+                  <a:srgbClr val="5B6770"/>
+                </a:solidFill>
+              </a:rPr>
+              <a:t>Improvement is positive when IRP is better. All delivery-ratio gains in fault scenarios are significant (Welch's t-test, p &lt; 0.05). The last row is the deliberate latency trade-off.</a:t>
+            </a:r>
+          </a:p>
+        </p:txBody>
+      </p:sp>
+    </p:spTree>
+  </p:cSld>
+  <p:clrMapOvr>
+    <a:masterClrMapping/>
+  </p:clrMapOvr>
+</p:sld>
+</file>
+
+<file path=ppt/slides/slide17.xml><?xml version="1.0" encoding="utf-8"?>
+<p:sld xmlns:a="http://schemas.openxmlformats.org/drawingml/2006/main" xmlns:p="http://schemas.openxmlformats.org/presentationml/2006/main" xmlns:r="http://schemas.openxmlformats.org/officeDocument/2006/relationships">
+  <p:cSld>
+    <p:spTree>
+      <p:nvGrpSpPr>
+        <p:cNvPr id="1" name=""/>
+        <p:cNvGrpSpPr/>
+        <p:nvPr/>
+      </p:nvGrpSpPr>
+      <p:grpSpPr/>
+      <p:sp>
+        <p:nvSpPr>
+          <p:cNvPr id="2" name="Text 0"/>
+          <p:cNvSpPr/>
+          <p:nvPr>
+            <p:ph idx="100" type="title" hasCustomPrompt="1"/>
+          </p:nvPr>
+        </p:nvSpPr>
+        <p:spPr>
+          <a:xfrm>
+            <a:off x="548640" y="365760"/>
+            <a:ext cx="11064240" cy="822960"/>
+          </a:xfrm>
+          <a:prstGeom prst="rect">
+            <a:avLst/>
+          </a:prstGeom>
+          <a:noFill/>
+          <a:ln/>
+        </p:spPr>
+        <p:txBody>
+          <a:bodyPr wrap="square" lIns="0" tIns="0" rIns="0" bIns="0" rtlCol="0" anchor="ctr"/>
+          <a:lstStyle/>
+          <a:p>
+            <a:pPr algn="l" indent="0" marL="0">
+              <a:buNone/>
+            </a:pPr>
+            <a:r>
+              <a:rPr lang="en-US" sz="3400" b="1" dirty="0">
+                <a:solidFill>
+                  <a:schemeClr val="tx2"/>
+                </a:solidFill>
+              </a:rPr>
+              <a:t>Conclusion, future work and references</a:t>
+            </a:r>
+            <a:endParaRPr lang="en-US" sz="3400" dirty="0"/>
+          </a:p>
+        </p:txBody>
+      </p:sp>
+      <p:sp>
+        <p:nvSpPr>
+          <p:cNvPr id="3" name="col0"/>
+          <p:cNvSpPr/>
+          <p:nvPr/>
+        </p:nvSpPr>
+        <p:spPr>
+          <a:xfrm>
+            <a:off x="548640" y="1508760"/>
+            <a:ext cx="3520440" cy="3749040"/>
+          </a:xfrm>
+          <a:prstGeom prst="roundRect">
+            <a:avLst>
+              <a:gd name="adj" fmla="val 3117"/>
+            </a:avLst>
+          </a:prstGeom>
+          <a:solidFill>
+            <a:srgbClr val="FFF6E0"/>
+          </a:solidFill>
+          <a:ln w="12700">
+            <a:solidFill>
+              <a:srgbClr val="FFF6E0"/>
+            </a:solidFill>
+            <a:prstDash val="solid"/>
+          </a:ln>
+        </p:spPr>
+      </p:sp>
+      <p:sp>
+        <p:nvSpPr>
+          <p:cNvPr id="4" name="Shape 2"/>
+          <p:cNvSpPr/>
+          <p:nvPr/>
+        </p:nvSpPr>
+        <p:spPr>
+          <a:xfrm>
+            <a:off x="822960" y="1783080"/>
+            <a:ext cx="365760" cy="365760"/>
+          </a:xfrm>
+          <a:prstGeom prst="ellipse">
+            <a:avLst/>
+          </a:prstGeom>
+          <a:solidFill>
+            <a:schemeClr val="accent3"/>
+          </a:solidFill>
+          <a:ln w="12700">
+            <a:solidFill>
+              <a:schemeClr val="accent3"/>
+            </a:solidFill>
+            <a:prstDash val="solid"/>
+          </a:ln>
+        </p:spPr>
+      </p:sp>
+      <p:sp>
+        <p:nvSpPr>
+          <p:cNvPr id="5" name="Text 3"/>
+          <p:cNvSpPr txBox="1"/>
+          <p:nvPr/>
+        </p:nvSpPr>
+        <p:spPr>
+          <a:xfrm>
+            <a:off x="1325880" y="1755648"/>
+            <a:ext cx="2560320" cy="411480"/>
+          </a:xfrm>
+          <a:prstGeom prst="rect">
+            <a:avLst/>
+          </a:prstGeom>
+          <a:noFill/>
+          <a:ln/>
+        </p:spPr>
+        <p:txBody>
+          <a:bodyPr wrap="square" lIns="0" tIns="0" rIns="0" bIns="0" rtlCol="0" anchor="ctr"/>
+          <a:lstStyle/>
+          <a:p>
+            <a:pPr indent="0" marL="0">
+              <a:buNone/>
+            </a:pPr>
+            <a:r>
+              <a:rPr lang="en-US" sz="2000" b="1" dirty="0">
+                <a:solidFill>
+                  <a:schemeClr val="tx2"/>
+                </a:solidFill>
+              </a:rPr>
+              <a:t>Conclusion</a:t>
+            </a:r>
+            <a:endParaRPr lang="en-US" sz="2000" dirty="0"/>
+          </a:p>
+        </p:txBody>
+      </p:sp>
+      <p:sp>
+        <p:nvSpPr>
+          <p:cNvPr id="6" name="Text 4"/>
+          <p:cNvSpPr txBox="1"/>
+          <p:nvPr/>
+        </p:nvSpPr>
+        <p:spPr>
+          <a:xfrm>
+            <a:off x="822960" y="2423160"/>
+            <a:ext cx="3017520" cy="2743200"/>
+          </a:xfrm>
+          <a:prstGeom prst="rect">
+            <a:avLst/>
+          </a:prstGeom>
+          <a:noFill/>
+          <a:ln/>
+        </p:spPr>
+        <p:txBody>
+          <a:bodyPr wrap="square" lIns="0" tIns="0" rIns="0" bIns="0" rtlCol="0" anchor="t"/>
+          <a:lstStyle/>
+          <a:p>
+            <a:pPr marL="342900" indent="-342900">
+              <a:spcAft>
+                <a:spcPts val="800"/>
+              </a:spcAft>
+              <a:buSzPct val="100000"/>
+              <a:buChar char="•"/>
+            </a:pPr>
+            <a:r>
+              <a:rPr lang="en-US" sz="1500" dirty="0">
+                <a:solidFill>
+                  <a:schemeClr val="tx1"/>
+                </a:solidFill>
+              </a:rPr>
+              <a:t>Same as OSPF on a healthy network.</a:t>
+            </a:r>
+            <a:endParaRPr lang="en-US" sz="1600" dirty="0"/>
+          </a:p>
+          <a:p>
+            <a:pPr marL="342900" indent="-342900">
+              <a:spcAft>
+                <a:spcPts val="800"/>
+              </a:spcAft>
+              <a:buSzPct val="100000"/>
+              <a:buChar char="•"/>
+            </a:pPr>
+            <a:r>
+              <a:rPr lang="en-US" sz="1500" dirty="0">
+                <a:solidFill>
+                  <a:schemeClr val="tx1"/>
+                </a:solidFill>
+              </a:rPr>
+              <a:t>Higher delivery in all 7 fault scenarios (p &lt; 0.05).</a:t>
+            </a:r>
+            <a:endParaRPr lang="en-US" sz="1600" dirty="0"/>
+          </a:p>
+          <a:p>
+            <a:pPr marL="342900" indent="-342900">
+              <a:spcAft>
+                <a:spcPts val="800"/>
+              </a:spcAft>
+              <a:buSzPct val="100000"/>
+              <a:buChar char="•"/>
+            </a:pPr>
+            <a:r>
+              <a:rPr lang="en-US" sz="1500" dirty="0">
+                <a:solidFill>
+                  <a:schemeClr val="tx1"/>
+                </a:solidFill>
+              </a:rPr>
+              <a:t>9× faster failure recovery; 2 vs 12 route changes on a flapping link.</a:t>
+            </a:r>
+            <a:endParaRPr lang="en-US" sz="1600" dirty="0"/>
+          </a:p>
+        </p:txBody>
+      </p:sp>
+      <p:sp>
+        <p:nvSpPr>
+          <p:cNvPr id="7" name="col1"/>
+          <p:cNvSpPr/>
+          <p:nvPr/>
+        </p:nvSpPr>
+        <p:spPr>
+          <a:xfrm>
+            <a:off x="4297680" y="1508760"/>
+            <a:ext cx="3520440" cy="3749040"/>
+          </a:xfrm>
+          <a:prstGeom prst="roundRect">
+            <a:avLst>
+              <a:gd name="adj" fmla="val 3117"/>
+            </a:avLst>
+          </a:prstGeom>
+          <a:solidFill>
+            <a:srgbClr val="FCEDE4"/>
+          </a:solidFill>
+          <a:ln w="12700">
+            <a:solidFill>
+              <a:srgbClr val="FCEDE4"/>
+            </a:solidFill>
+            <a:prstDash val="solid"/>
+          </a:ln>
+        </p:spPr>
+      </p:sp>
+      <p:sp>
+        <p:nvSpPr>
+          <p:cNvPr id="8" name="Shape 6"/>
+          <p:cNvSpPr/>
+          <p:nvPr/>
+        </p:nvSpPr>
+        <p:spPr>
+          <a:xfrm>
+            <a:off x="4572000" y="1783080"/>
+            <a:ext cx="365760" cy="365760"/>
+          </a:xfrm>
+          <a:prstGeom prst="ellipse">
+            <a:avLst/>
+          </a:prstGeom>
+          <a:solidFill>
+            <a:schemeClr val="accent2"/>
+          </a:solidFill>
+          <a:ln w="12700">
+            <a:solidFill>
+              <a:schemeClr val="accent2"/>
+            </a:solidFill>
+            <a:prstDash val="solid"/>
+          </a:ln>
+        </p:spPr>
+      </p:sp>
+      <p:sp>
+        <p:nvSpPr>
+          <p:cNvPr id="9" name="Text 7"/>
+          <p:cNvSpPr txBox="1"/>
+          <p:nvPr/>
+        </p:nvSpPr>
+        <p:spPr>
+          <a:xfrm>
+            <a:off x="5074920" y="1755648"/>
+            <a:ext cx="2560320" cy="411480"/>
+          </a:xfrm>
+          <a:prstGeom prst="rect">
+            <a:avLst/>
+          </a:prstGeom>
+          <a:noFill/>
+          <a:ln/>
+        </p:spPr>
+        <p:txBody>
+          <a:bodyPr wrap="square" lIns="0" tIns="0" rIns="0" bIns="0" rtlCol="0" anchor="ctr"/>
+          <a:lstStyle/>
+          <a:p>
+            <a:pPr indent="0" marL="0">
+              <a:buNone/>
+            </a:pPr>
+            <a:r>
+              <a:rPr lang="en-US" sz="2000" b="1" dirty="0">
+                <a:solidFill>
+                  <a:schemeClr val="tx2"/>
+                </a:solidFill>
+              </a:rPr>
+              <a:t>Future work</a:t>
+            </a:r>
+            <a:endParaRPr lang="en-US" sz="2000" dirty="0"/>
+          </a:p>
+        </p:txBody>
+      </p:sp>
+      <p:sp>
+        <p:nvSpPr>
+          <p:cNvPr id="10" name="Text 8"/>
+          <p:cNvSpPr txBox="1"/>
+          <p:nvPr/>
+        </p:nvSpPr>
+        <p:spPr>
+          <a:xfrm>
+            <a:off x="4572000" y="2423160"/>
+            <a:ext cx="3017520" cy="2743200"/>
+          </a:xfrm>
+          <a:prstGeom prst="rect">
+            <a:avLst/>
+          </a:prstGeom>
+          <a:noFill/>
+          <a:ln/>
+        </p:spPr>
+        <p:txBody>
+          <a:bodyPr wrap="square" lIns="0" tIns="0" rIns="0" bIns="0" rtlCol="0" anchor="t"/>
+          <a:lstStyle/>
+          <a:p>
+            <a:pPr marL="342900" indent="-342900">
+              <a:spcAft>
+                <a:spcPts val="800"/>
+              </a:spcAft>
+              <a:buSzPct val="100000"/>
+              <a:buChar char="•"/>
+            </a:pPr>
+            <a:r>
+              <a:rPr lang="en-US" sz="1500" dirty="0">
+                <a:solidFill>
+                  <a:schemeClr val="tx1"/>
+                </a:solidFill>
+              </a:rPr>
+              <a:t>Learn the weights automatically (Bayesian optimisation).</a:t>
+            </a:r>
+            <a:endParaRPr lang="en-US" sz="1600" dirty="0"/>
+          </a:p>
+          <a:p>
+            <a:pPr marL="342900" indent="-342900">
+              <a:spcAft>
+                <a:spcPts val="800"/>
+              </a:spcAft>
+              <a:buSzPct val="100000"/>
+              <a:buChar char="•"/>
+            </a:pPr>
+            <a:r>
+              <a:rPr lang="en-US" sz="1500" dirty="0">
+                <a:solidFill>
+                  <a:schemeClr val="tx1"/>
+                </a:solidFill>
+              </a:rPr>
+              <a:t>Packet-level validation in Mininet or ns-3.</a:t>
+            </a:r>
+            <a:endParaRPr lang="en-US" sz="1600" dirty="0"/>
+          </a:p>
+          <a:p>
+            <a:pPr marL="342900" indent="-342900">
+              <a:spcAft>
+                <a:spcPts val="800"/>
+              </a:spcAft>
+              <a:buSzPct val="100000"/>
+              <a:buChar char="•"/>
+            </a:pPr>
+            <a:r>
+              <a:rPr lang="en-US" sz="1500" dirty="0">
+                <a:solidFill>
+                  <a:schemeClr val="tx1"/>
+                </a:solidFill>
+              </a:rPr>
+              <a:t>Distributed version: routers flood their measurements.</a:t>
+            </a:r>
+            <a:endParaRPr lang="en-US" sz="1600" dirty="0"/>
+          </a:p>
+        </p:txBody>
+      </p:sp>
+      <p:sp>
+        <p:nvSpPr>
+          <p:cNvPr id="11" name="col2"/>
+          <p:cNvSpPr/>
+          <p:nvPr/>
+        </p:nvSpPr>
+        <p:spPr>
+          <a:xfrm>
+            <a:off x="8046720" y="1508760"/>
+            <a:ext cx="3520440" cy="3749040"/>
+          </a:xfrm>
+          <a:prstGeom prst="roundRect">
+            <a:avLst>
+              <a:gd name="adj" fmla="val 3117"/>
+            </a:avLst>
+          </a:prstGeom>
+          <a:solidFill>
+            <a:srgbClr val="E3F2EF"/>
+          </a:solidFill>
+          <a:ln w="12700">
+            <a:solidFill>
+              <a:srgbClr val="E3F2EF"/>
+            </a:solidFill>
+            <a:prstDash val="solid"/>
+          </a:ln>
+        </p:spPr>
+      </p:sp>
+      <p:sp>
+        <p:nvSpPr>
+          <p:cNvPr id="12" name="Shape 10"/>
+          <p:cNvSpPr/>
+          <p:nvPr/>
+        </p:nvSpPr>
+        <p:spPr>
+          <a:xfrm>
+            <a:off x="8321040" y="1783080"/>
+            <a:ext cx="365760" cy="365760"/>
+          </a:xfrm>
+          <a:prstGeom prst="ellipse">
+            <a:avLst/>
+          </a:prstGeom>
+          <a:solidFill>
+            <a:schemeClr val="accent1"/>
+          </a:solidFill>
+          <a:ln w="12700">
+            <a:solidFill>
+              <a:schemeClr val="accent1"/>
+            </a:solidFill>
+            <a:prstDash val="solid"/>
+          </a:ln>
+        </p:spPr>
+      </p:sp>
+      <p:sp>
+        <p:nvSpPr>
+          <p:cNvPr id="13" name="Text 11"/>
+          <p:cNvSpPr txBox="1"/>
+          <p:nvPr/>
+        </p:nvSpPr>
+        <p:spPr>
+          <a:xfrm>
+            <a:off x="8823960" y="1755648"/>
+            <a:ext cx="2560320" cy="411480"/>
+          </a:xfrm>
+          <a:prstGeom prst="rect">
+            <a:avLst/>
+          </a:prstGeom>
+          <a:noFill/>
+          <a:ln/>
+        </p:spPr>
+        <p:txBody>
+          <a:bodyPr wrap="square" lIns="0" tIns="0" rIns="0" bIns="0" rtlCol="0" anchor="ctr"/>
+          <a:lstStyle/>
+          <a:p>
+            <a:pPr indent="0" marL="0">
+              <a:buNone/>
+            </a:pPr>
+            <a:r>
+              <a:rPr lang="en-US" sz="2000" b="1" dirty="0">
+                <a:solidFill>
+                  <a:schemeClr val="tx2"/>
+                </a:solidFill>
+              </a:rPr>
+              <a:t>References</a:t>
+            </a:r>
+            <a:endParaRPr lang="en-US" sz="2000" dirty="0"/>
+          </a:p>
+        </p:txBody>
+      </p:sp>
+      <p:sp>
+        <p:nvSpPr>
+          <p:cNvPr id="14" name="Text 12"/>
+          <p:cNvSpPr txBox="1"/>
+          <p:nvPr/>
+        </p:nvSpPr>
+        <p:spPr>
+          <a:xfrm>
+            <a:off x="8321040" y="2423160"/>
+            <a:ext cx="3017520" cy="2743200"/>
+          </a:xfrm>
+          <a:prstGeom prst="rect">
+            <a:avLst/>
+          </a:prstGeom>
+          <a:noFill/>
+          <a:ln/>
+        </p:spPr>
+        <p:txBody>
+          <a:bodyPr wrap="square" lIns="0" tIns="0" rIns="0" bIns="0" rtlCol="0" anchor="t"/>
+          <a:lstStyle/>
+          <a:p>
+            <a:pPr marL="342900" indent="-342900">
+              <a:spcAft>
+                <a:spcPts val="800"/>
+              </a:spcAft>
+              <a:buSzPct val="100000"/>
+              <a:buChar char="•"/>
+            </a:pPr>
+            <a:r>
+              <a:rPr lang="en-US" sz="1100" dirty="0">
+                <a:solidFill>
+                  <a:schemeClr val="tx1"/>
+                </a:solidFill>
+              </a:rPr>
+              <a:t>J. Moy, "OSPF Version 2," RFC 2328, 1998.</a:t>
+            </a:r>
+            <a:endParaRPr lang="en-US" sz="1600" dirty="0"/>
+          </a:p>
+          <a:p>
+            <a:pPr marL="342900" indent="-342900">
+              <a:spcAft>
+                <a:spcPts val="800"/>
+              </a:spcAft>
+              <a:buSzPct val="100000"/>
+              <a:buChar char="•"/>
+            </a:pPr>
+            <a:r>
+              <a:rPr lang="en-US" sz="1100" dirty="0">
+                <a:solidFill>
+                  <a:schemeClr val="tx1"/>
+                </a:solidFill>
+              </a:rPr>
+              <a:t>C. Hedrick, "Routing Information Protocol," RFC 1058, 1988.</a:t>
+            </a:r>
+            <a:endParaRPr lang="en-US" sz="1600" dirty="0"/>
+          </a:p>
+          <a:p>
+            <a:pPr marL="342900" indent="-342900">
+              <a:spcAft>
+                <a:spcPts val="800"/>
+              </a:spcAft>
+              <a:buSzPct val="100000"/>
+              <a:buChar char="•"/>
+            </a:pPr>
+            <a:r>
+              <a:rPr lang="en-US" sz="1100" dirty="0">
+                <a:solidFill>
+                  <a:schemeClr val="tx1"/>
+                </a:solidFill>
+              </a:rPr>
+              <a:t>A. Khanna, J. Zinky, "The revised ARPANET routing metric," SIGCOMM 1989.</a:t>
+            </a:r>
+            <a:endParaRPr lang="en-US" sz="1600" dirty="0"/>
+          </a:p>
+          <a:p>
+            <a:pPr marL="342900" indent="-342900">
+              <a:spcAft>
+                <a:spcPts val="800"/>
+              </a:spcAft>
+              <a:buSzPct val="100000"/>
+              <a:buChar char="•"/>
+            </a:pPr>
+            <a:r>
+              <a:rPr lang="en-US" sz="1100" dirty="0">
+                <a:solidFill>
+                  <a:schemeClr val="tx1"/>
+                </a:solidFill>
+              </a:rPr>
+              <a:t>D. De Couto et al., "A high-throughput path metric for multi-hop wireless routing," MobiCom 2003.</a:t>
+            </a:r>
+            <a:endParaRPr lang="en-US" sz="1600" dirty="0"/>
+          </a:p>
+          <a:p>
+            <a:pPr marL="342900" indent="-342900">
+              <a:spcAft>
+                <a:spcPts val="800"/>
+              </a:spcAft>
+              <a:buSzPct val="100000"/>
+              <a:buChar char="•"/>
+            </a:pPr>
+            <a:r>
+              <a:rPr lang="en-US" sz="1100" dirty="0">
+                <a:solidFill>
+                  <a:schemeClr val="tx1"/>
+                </a:solidFill>
+              </a:rPr>
+              <a:t>S. Kandula et al., "Walking the tightrope," SIGCOMM 2005.</a:t>
+            </a:r>
+            <a:endParaRPr lang="en-US" sz="1600" dirty="0"/>
+          </a:p>
+        </p:txBody>
+      </p:sp>
+      <p:sp>
+        <p:nvSpPr>
+          <p:cNvPr id="15" name="Text 13"/>
+          <p:cNvSpPr txBox="1"/>
+          <p:nvPr/>
+        </p:nvSpPr>
+        <p:spPr>
+          <a:xfrm>
+            <a:off x="548640" y="5577840"/>
+            <a:ext cx="11064240" cy="411480"/>
+          </a:xfrm>
+          <a:prstGeom prst="rect">
+            <a:avLst/>
+          </a:prstGeom>
+          <a:noFill/>
+          <a:ln/>
+        </p:spPr>
+        <p:txBody>
+          <a:bodyPr wrap="square" lIns="0" tIns="0" rIns="0" bIns="0" rtlCol="0" anchor="t"/>
+          <a:lstStyle/>
+          <a:p>
+            <a:pPr indent="0" marL="0">
+              <a:buNone/>
+            </a:pPr>
+            <a:r>
+              <a:rPr lang="en-US" sz="1500" i="1" dirty="0">
+                <a:solidFill>
+                  <a:schemeClr val="accent4"/>
+                </a:solidFill>
+              </a:rPr>
+              <a:t>Full IEEE reference list in the report.  Code: github.com/nehadamani0909/F2_Team18</a:t>
+            </a:r>
+            <a:endParaRPr lang="en-US" sz="1500" dirty="0"/>
+          </a:p>
+        </p:txBody>
+      </p:sp>
+      <p:sp>
+        <p:nvSpPr>
+          <p:cNvPr id="25" name="Slide Number Placeholder 0"/>
+          <p:cNvSpPr>
+            <a:spLocks noGrp="1"/>
+          </p:cNvSpPr>
+          <p:nvPr>
+            <p:ph type="sldNum" sz="quarter" idx="4294967295"/>
+          </p:nvPr>
+        </p:nvSpPr>
+        <p:spPr>
+          <a:xfrm>
+            <a:off x="11247120" y="6400800"/>
+            <a:ext cx="548640" cy="274320"/>
+          </a:xfrm>
+          <a:prstGeom prst="rect">
+            <a:avLst/>
+          </a:prstGeom>
+          <a:extLst>
+            <a:ext uri="{C572A759-6A51-4108-AA02-DFA0A04FC94B}">
+              <ma14:wrappingTextBoxFlag xmlns:ma14="http://schemas.microsoft.com/office/mac/drawingml/2011/main" val="0"/>
+            </a:ext>
+          </a:extLst>
+        </p:spPr>
+        <p:txBody>
+          <a:bodyPr/>
+          <a:lstStyle>
+            <a:lvl1pPr>
+              <a:defRPr sz="1000">
+                <a:solidFill>
+                  <a:srgbClr val="8A949B"/>
+                </a:solidFill>
+              </a:defRPr>
+            </a:lvl1pPr>
+          </a:lstStyle>
+          <a:p>
+            <a:pPr algn="r"/>
+            <a:fld id="{F7021451-1387-4CA6-816F-3879F97B5CBC}" type="slidenum">
+              <a:rPr b="0" lang="en-US"/>
+              <a:t>12</a:t>
+            </a:fld>
+            <a:endParaRPr lang="en-US"/>
+          </a:p>
+        </p:txBody>
+      </p:sp>
+    </p:spTree>
+  </p:cSld>
+  <p:clrMapOvr>
+    <a:masterClrMapping/>
+  </p:clrMapOvr>
+</p:sld>
+</file>
+
 <file path=ppt/slides/slide2.xml><?xml version="1.0" encoding="utf-8"?>
 <p:sld xmlns:a="http://schemas.openxmlformats.org/drawingml/2006/main" xmlns:r="http://schemas.openxmlformats.org/officeDocument/2006/relationships" xmlns:p="http://schemas.openxmlformats.org/presentationml/2006/main">
   <p:cSld name="Slide 2">
@@ -4576,7 +7629,7 @@
                   <a:schemeClr val="tx2"/>
                 </a:solidFill>
               </a:rPr>
-              <a:t>The shortest path is not always the best path</a:t>
+              <a:t>Problem and motivation: shortest is not always best</a:t>
             </a:r>
             <a:endParaRPr lang="en-US" sz="3400" dirty="0"/>
           </a:p>
@@ -5326,7 +8379,7 @@
                   <a:schemeClr val="tx2"/>
                 </a:solidFill>
               </a:rPr>
-              <a:t>The idea: score every link on four live measurements</a:t>
+              <a:t>Proposed novelty: four live measurements per link</a:t>
             </a:r>
             <a:endParaRPr lang="en-US" sz="3400" dirty="0"/>
           </a:p>
@@ -6148,7 +9201,7 @@
                   <a:schemeClr val="tx2"/>
                 </a:solidFill>
               </a:rPr>
-              <a:t>How it works: measure, score, choose, stay stable</a:t>
+              <a:t>Architecture: measure, score, choose, stay stable</a:t>
             </a:r>
             <a:endParaRPr lang="en-US" sz="3400" dirty="0"/>
           </a:p>
@@ -7230,7 +10283,7 @@
                   <a:schemeClr val="tx2"/>
                 </a:solidFill>
               </a:rPr>
-              <a:t>One cost per link, in “effective milliseconds”</a:t>
+              <a:t>Algorithm: one cost per link, in effective milliseconds</a:t>
             </a:r>
             <a:endParaRPr lang="en-US" sz="3400" dirty="0"/>
           </a:p>
@@ -7828,7 +10881,7 @@
                   <a:schemeClr val="tx2"/>
                 </a:solidFill>
               </a:rPr>
-              <a:t>Adapting fast without flip-flopping</a:t>
+              <a:t>Algorithm: adapting fast without flip-flopping</a:t>
             </a:r>
             <a:endParaRPr lang="en-US" sz="3400" dirty="0"/>
           </a:p>
@@ -8524,7 +11577,7 @@
                   <a:schemeClr val="tx2"/>
                 </a:solidFill>
               </a:rPr>
-              <a:t>How we tested it</a:t>
+              <a:t>Scenarios and metrics</a:t>
             </a:r>
             <a:endParaRPr lang="en-US" sz="3400" dirty="0"/>
           </a:p>
@@ -9650,8 +12703,8 @@
         </p:nvSpPr>
         <p:spPr>
           <a:xfrm>
-            <a:off x="6492240" y="4617720"/>
-            <a:ext cx="5120640" cy="1463040"/>
+            <a:off x="6492240" y="4480560"/>
+            <a:ext cx="5120640" cy="1645920"/>
           </a:xfrm>
           <a:prstGeom prst="roundRect">
             <a:avLst>
@@ -9677,8 +12730,8 @@
         </p:nvSpPr>
         <p:spPr>
           <a:xfrm>
-            <a:off x="6720840" y="4754880"/>
-            <a:ext cx="4663440" cy="1188720"/>
+            <a:off x="6720840" y="4572000"/>
+            <a:ext cx="4663440" cy="1463040"/>
           </a:xfrm>
           <a:prstGeom prst="rect">
             <a:avLst/>
@@ -9694,23 +12747,23 @@
               <a:buNone/>
             </a:pPr>
             <a:r>
-              <a:rPr lang="en-US" sz="1500" b="1" dirty="0">
+              <a:rPr lang="en-US" sz="1300" b="1" dirty="0">
                 <a:solidFill>
                   <a:schemeClr val="tx2"/>
                 </a:solidFill>
               </a:rPr>
-              <a:t>Compared against: </a:t>
+              <a:t>Metrics: </a:t>
             </a:r>
             <a:pPr indent="0" marL="0">
               <a:buNone/>
             </a:pPr>
             <a:r>
-              <a:rPr lang="en-US" sz="1500" dirty="0">
+              <a:rPr lang="en-US" sz="1300" dirty="0">
                 <a:solidFill>
                   <a:schemeClr val="tx1"/>
                 </a:solidFill>
               </a:rPr>
-              <a:t>OSPF-like static routing, latency-only dynamic routing, and RIP-like hop count. 10 random seeds each, Welch's t-test (p &lt; 0.05).</a:t>
+              <a:t>delivery ratio, throughput, mean / p95 latency, recovery time, time degraded, route changes. Baselines: OSPF-like, latency-only, hop count. 10 seeds each, Welch's t-test.</a:t>
             </a:r>
             <a:endParaRPr lang="en-US" sz="1500" dirty="0"/>
           </a:p>
@@ -9818,7 +12871,7 @@
                   <a:schemeClr val="tx2"/>
                 </a:solidFill>
               </a:rPr>
-              <a:t>Headline results vs. OSPF-like routing</a:t>
+              <a:t>Results: headline numbers vs OSPF-like routing</a:t>
             </a:r>
             <a:endParaRPr lang="en-US" sz="3400" dirty="0"/>
           </a:p>
@@ -10552,7 +13605,7 @@
                   <a:schemeClr val="tx2"/>
                 </a:solidFill>
               </a:rPr>
-              <a:t>Time with degraded service during a 25-second fault</a:t>
+              <a:t>Results: time with degraded service during a 25 s fault</a:t>
             </a:r>
             <a:endParaRPr lang="en-US" sz="3400" dirty="0"/>
           </a:p>

</xml_diff>